<commit_message>
System Design vi: sd-14-027 deck updated for the IPv4/IPv6 full-tunnel list
Co-Authored-By: Claude Sonnet 5.5 <noreply@anthropic.com>
Claude-Session: https://claude.ai/code/session_01WnjciXNJBLEd8jy3HrG49S
</commit_message>
<xml_diff>
--- a/system-design-101/vi/lessons/sd-14-027/slides/sd-14-027.pptx
+++ b/system-design-101/vi/lessons/sd-14-027/slides/sd-14-027.pptx
@@ -3380,7 +3380,7 @@
               <a:t> vào</a:t>
             </a:r>
             <a:r>
-              <a:rPr lang="en-US" sz="1800" dirty="0" spc="1" kern="0">
+              <a:rPr lang="en-US" sz="1800" dirty="0" spc="0" kern="0">
                 <a:solidFill>
                   <a:srgbClr val="3DD6A0"/>
                 </a:solidFill>
@@ -3388,7 +3388,51 @@
                 <a:ea typeface="Be Vietnam Pro SemiBold" pitchFamily="34" charset="-122"/>
                 <a:cs typeface="Be Vietnam Pro SemiBold" pitchFamily="34" charset="-120"/>
               </a:rPr>
-              <a:t> hầm</a:t>
+              <a:t> hầm,</a:t>
+            </a:r>
+            <a:r>
+              <a:rPr lang="en-US" sz="1800" dirty="0" spc="-2" kern="0">
+                <a:solidFill>
+                  <a:srgbClr val="3DD6A0"/>
+                </a:solidFill>
+                <a:latin typeface="Be Vietnam Pro SemiBold" pitchFamily="34" charset="0"/>
+                <a:ea typeface="Be Vietnam Pro SemiBold" pitchFamily="34" charset="-122"/>
+                <a:cs typeface="Be Vietnam Pro SemiBold" pitchFamily="34" charset="-120"/>
+              </a:rPr>
+              <a:t> cả</a:t>
+            </a:r>
+            <a:r>
+              <a:rPr lang="en-US" sz="1800" dirty="0" spc="1" kern="0">
+                <a:solidFill>
+                  <a:srgbClr val="3DD6A0"/>
+                </a:solidFill>
+                <a:latin typeface="Be Vietnam Pro SemiBold" pitchFamily="34" charset="0"/>
+                <a:ea typeface="Be Vietnam Pro SemiBold" pitchFamily="34" charset="-122"/>
+                <a:cs typeface="Be Vietnam Pro SemiBold" pitchFamily="34" charset="-120"/>
+              </a:rPr>
+              <a:t> IPv4</a:t>
+            </a:r>
+            <a:r>
+              <a:rPr lang="en-US" sz="1800" dirty="0" spc="-1" kern="0">
+                <a:solidFill>
+                  <a:srgbClr val="3DD6A0"/>
+                </a:solidFill>
+                <a:latin typeface="Be Vietnam Pro SemiBold" pitchFamily="34" charset="0"/>
+                <a:ea typeface="Be Vietnam Pro SemiBold" pitchFamily="34" charset="-122"/>
+                <a:cs typeface="Be Vietnam Pro SemiBold" pitchFamily="34" charset="-120"/>
+              </a:rPr>
+              <a:t> lẫn</a:t>
+            </a:r>
+            <a:r>
+              <a:rPr lang="en-US" sz="1800" dirty="0" spc="-9" kern="0">
+                <a:solidFill>
+                  <a:srgbClr val="3DD6A0"/>
+                </a:solidFill>
+                <a:latin typeface="Be Vietnam Pro SemiBold" pitchFamily="34" charset="0"/>
+                <a:ea typeface="Be Vietnam Pro SemiBold" pitchFamily="34" charset="-122"/>
+                <a:cs typeface="Be Vietnam Pro SemiBold" pitchFamily="34" charset="-120"/>
+              </a:rPr>
+              <a:t> IPv6</a:t>
             </a:r>
             <a:endParaRPr lang="en-US" sz="1800" dirty="0"/>
           </a:p>
@@ -5516,8 +5560,8 @@
         </p:nvSpPr>
         <p:spPr>
           <a:xfrm>
-            <a:off x="12325350" y="5524500"/>
-            <a:ext cx="4762500" cy="285750"/>
+            <a:off x="914400" y="7924800"/>
+            <a:ext cx="8572500" cy="285750"/>
           </a:xfrm>
           <a:prstGeom prst="rect">
             <a:avLst/>
@@ -5533,37 +5577,37 @@
               <a:buNone/>
             </a:pPr>
             <a:r>
-              <a:rPr lang="en-US" sz="1650" b="1" spc="226" kern="0" dirty="0">
-                <a:solidFill>
-                  <a:srgbClr val="9A98A0"/>
-                </a:solidFill>
-                <a:latin typeface="Be Vietnam Pro" pitchFamily="34" charset="0"/>
-                <a:ea typeface="Be Vietnam Pro" pitchFamily="34" charset="-122"/>
-                <a:cs typeface="Be Vietnam Pro" pitchFamily="34" charset="-120"/>
-              </a:rPr>
-              <a:t>MÀU</a:t>
-            </a:r>
-            <a:r>
-              <a:rPr lang="en-US" sz="1650" b="1" spc="217" kern="0" dirty="0">
-                <a:solidFill>
-                  <a:srgbClr val="9A98A0"/>
-                </a:solidFill>
-                <a:latin typeface="Be Vietnam Pro" pitchFamily="34" charset="0"/>
-                <a:ea typeface="Be Vietnam Pro" pitchFamily="34" charset="-122"/>
-                <a:cs typeface="Be Vietnam Pro" pitchFamily="34" charset="-120"/>
-              </a:rPr>
-              <a:t> TRONG</a:t>
-            </a:r>
-            <a:r>
-              <a:rPr lang="en-US" sz="1650" b="1" spc="220" kern="0" dirty="0">
-                <a:solidFill>
-                  <a:srgbClr val="9A98A0"/>
-                </a:solidFill>
-                <a:latin typeface="Be Vietnam Pro" pitchFamily="34" charset="0"/>
-                <a:ea typeface="Be Vietnam Pro" pitchFamily="34" charset="-122"/>
-                <a:cs typeface="Be Vietnam Pro" pitchFamily="34" charset="-120"/>
-              </a:rPr>
-              <a:t> BÀI</a:t>
+              <a:rPr lang="en-US" sz="1650" b="1" spc="227" kern="0" dirty="0">
+                <a:solidFill>
+                  <a:srgbClr val="FF6A4D"/>
+                </a:solidFill>
+                <a:latin typeface="Be Vietnam Pro" pitchFamily="34" charset="0"/>
+                <a:ea typeface="Be Vietnam Pro" pitchFamily="34" charset="-122"/>
+                <a:cs typeface="Be Vietnam Pro" pitchFamily="34" charset="-120"/>
+              </a:rPr>
+              <a:t>NGUỒN</a:t>
+            </a:r>
+            <a:r>
+              <a:rPr lang="en-US" sz="1650" b="1" spc="229" kern="0" dirty="0">
+                <a:solidFill>
+                  <a:srgbClr val="FF6A4D"/>
+                </a:solidFill>
+                <a:latin typeface="Be Vietnam Pro" pitchFamily="34" charset="0"/>
+                <a:ea typeface="Be Vietnam Pro" pitchFamily="34" charset="-122"/>
+                <a:cs typeface="Be Vietnam Pro" pitchFamily="34" charset="-120"/>
+              </a:rPr>
+              <a:t> ĐỐI</a:t>
+            </a:r>
+            <a:r>
+              <a:rPr lang="en-US" sz="1650" b="1" spc="227" kern="0" dirty="0">
+                <a:solidFill>
+                  <a:srgbClr val="FF6A4D"/>
+                </a:solidFill>
+                <a:latin typeface="Be Vietnam Pro" pitchFamily="34" charset="0"/>
+                <a:ea typeface="Be Vietnam Pro" pitchFamily="34" charset="-122"/>
+                <a:cs typeface="Be Vietnam Pro" pitchFamily="34" charset="-120"/>
+              </a:rPr>
+              <a:t> CHIẾU</a:t>
             </a:r>
             <a:endParaRPr lang="en-US" sz="1650" dirty="0"/>
           </a:p>
@@ -5571,360 +5615,14 @@
       </p:sp>
       <p:sp>
         <p:nvSpPr>
-          <p:cNvPr id="36" name="Shape 34"/>
-          <p:cNvSpPr/>
-          <p:nvPr/>
-        </p:nvSpPr>
-        <p:spPr>
-          <a:xfrm>
-            <a:off x="12344400" y="5981700"/>
-            <a:ext cx="228600" cy="228600"/>
-          </a:xfrm>
-          <a:prstGeom prst="ellipse">
-            <a:avLst/>
-          </a:prstGeom>
-          <a:solidFill>
-            <a:srgbClr val="7C93FF"/>
-          </a:solidFill>
-          <a:ln/>
-        </p:spPr>
-      </p:sp>
-      <p:sp>
-        <p:nvSpPr>
-          <p:cNvPr id="37" name="Text 35"/>
-          <p:cNvSpPr/>
-          <p:nvPr/>
-        </p:nvSpPr>
-        <p:spPr>
-          <a:xfrm>
-            <a:off x="12744450" y="5924550"/>
-            <a:ext cx="4381500" cy="342900"/>
-          </a:xfrm>
-          <a:prstGeom prst="rect">
-            <a:avLst/>
-          </a:prstGeom>
-          <a:noFill/>
-          <a:ln/>
-        </p:spPr>
-        <p:txBody>
-          <a:bodyPr wrap="square" lIns="0" tIns="0" rIns="0" bIns="0" rtlCol="0" anchor="ctr"/>
-          <a:lstStyle/>
-          <a:p>
-            <a:pPr algn="l" indent="0" marL="0">
-              <a:buNone/>
-            </a:pPr>
-            <a:r>
-              <a:rPr lang="en-US" sz="1950" dirty="0" spc="-28" kern="0">
-                <a:solidFill>
-                  <a:srgbClr val="7C93FF"/>
-                </a:solidFill>
-                <a:latin typeface="Be Vietnam Pro SemiBold" pitchFamily="34" charset="0"/>
-                <a:ea typeface="Be Vietnam Pro SemiBold" pitchFamily="34" charset="-122"/>
-                <a:cs typeface="Be Vietnam Pro SemiBold" pitchFamily="34" charset="-120"/>
-              </a:rPr>
-              <a:t>Truy</a:t>
-            </a:r>
-            <a:r>
-              <a:rPr lang="en-US" sz="1950" dirty="0" spc="0" kern="0">
-                <a:solidFill>
-                  <a:srgbClr val="7C93FF"/>
-                </a:solidFill>
-                <a:latin typeface="Be Vietnam Pro SemiBold" pitchFamily="34" charset="0"/>
-                <a:ea typeface="Be Vietnam Pro SemiBold" pitchFamily="34" charset="-122"/>
-                <a:cs typeface="Be Vietnam Pro SemiBold" pitchFamily="34" charset="-120"/>
-              </a:rPr>
-              <a:t> cập từ</a:t>
-            </a:r>
-            <a:r>
-              <a:rPr lang="en-US" sz="1950" dirty="0" spc="-23" kern="0">
-                <a:solidFill>
-                  <a:srgbClr val="7C93FF"/>
-                </a:solidFill>
-                <a:latin typeface="Be Vietnam Pro SemiBold" pitchFamily="34" charset="0"/>
-                <a:ea typeface="Be Vietnam Pro SemiBold" pitchFamily="34" charset="-122"/>
-                <a:cs typeface="Be Vietnam Pro SemiBold" pitchFamily="34" charset="-120"/>
-              </a:rPr>
-              <a:t> xa</a:t>
-            </a:r>
-            <a:endParaRPr lang="en-US" sz="1950" dirty="0"/>
-          </a:p>
-        </p:txBody>
-      </p:sp>
-      <p:sp>
-        <p:nvSpPr>
-          <p:cNvPr id="38" name="Shape 36"/>
-          <p:cNvSpPr/>
-          <p:nvPr/>
-        </p:nvSpPr>
-        <p:spPr>
-          <a:xfrm>
-            <a:off x="12344400" y="6381750"/>
-            <a:ext cx="228600" cy="228600"/>
-          </a:xfrm>
-          <a:prstGeom prst="ellipse">
-            <a:avLst/>
-          </a:prstGeom>
-          <a:solidFill>
-            <a:srgbClr val="FFB454"/>
-          </a:solidFill>
-          <a:ln/>
-        </p:spPr>
-      </p:sp>
-      <p:sp>
-        <p:nvSpPr>
-          <p:cNvPr id="39" name="Text 37"/>
-          <p:cNvSpPr/>
-          <p:nvPr/>
-        </p:nvSpPr>
-        <p:spPr>
-          <a:xfrm>
-            <a:off x="12744450" y="6324600"/>
-            <a:ext cx="4381500" cy="342900"/>
-          </a:xfrm>
-          <a:prstGeom prst="rect">
-            <a:avLst/>
-          </a:prstGeom>
-          <a:noFill/>
-          <a:ln/>
-        </p:spPr>
-        <p:txBody>
-          <a:bodyPr wrap="square" lIns="0" tIns="0" rIns="0" bIns="0" rtlCol="0" anchor="ctr"/>
-          <a:lstStyle/>
-          <a:p>
-            <a:pPr algn="l" indent="0" marL="0">
-              <a:buNone/>
-            </a:pPr>
-            <a:r>
-              <a:rPr lang="en-US" sz="1950" dirty="0" spc="0" kern="0">
-                <a:solidFill>
-                  <a:srgbClr val="FFB454"/>
-                </a:solidFill>
-                <a:latin typeface="Be Vietnam Pro SemiBold" pitchFamily="34" charset="0"/>
-                <a:ea typeface="Be Vietnam Pro SemiBold" pitchFamily="34" charset="-122"/>
-                <a:cs typeface="Be Vietnam Pro SemiBold" pitchFamily="34" charset="-120"/>
-              </a:rPr>
-              <a:t>Nối</a:t>
-            </a:r>
-            <a:r>
-              <a:rPr lang="en-US" sz="1950" dirty="0" spc="-2" kern="0">
-                <a:solidFill>
-                  <a:srgbClr val="FFB454"/>
-                </a:solidFill>
-                <a:latin typeface="Be Vietnam Pro SemiBold" pitchFamily="34" charset="0"/>
-                <a:ea typeface="Be Vietnam Pro SemiBold" pitchFamily="34" charset="-122"/>
-                <a:cs typeface="Be Vietnam Pro SemiBold" pitchFamily="34" charset="-120"/>
-              </a:rPr>
-              <a:t> hai</a:t>
-            </a:r>
-            <a:r>
-              <a:rPr lang="en-US" sz="1950" dirty="0" spc="-3" kern="0">
-                <a:solidFill>
-                  <a:srgbClr val="FFB454"/>
-                </a:solidFill>
-                <a:latin typeface="Be Vietnam Pro SemiBold" pitchFamily="34" charset="0"/>
-                <a:ea typeface="Be Vietnam Pro SemiBold" pitchFamily="34" charset="-122"/>
-                <a:cs typeface="Be Vietnam Pro SemiBold" pitchFamily="34" charset="-120"/>
-              </a:rPr>
-              <a:t> mạng</a:t>
-            </a:r>
-            <a:endParaRPr lang="en-US" sz="1950" dirty="0"/>
-          </a:p>
-        </p:txBody>
-      </p:sp>
-      <p:sp>
-        <p:nvSpPr>
-          <p:cNvPr id="40" name="Shape 38"/>
-          <p:cNvSpPr/>
-          <p:nvPr/>
-        </p:nvSpPr>
-        <p:spPr>
-          <a:xfrm>
-            <a:off x="12344400" y="6781800"/>
-            <a:ext cx="228600" cy="228600"/>
-          </a:xfrm>
-          <a:prstGeom prst="ellipse">
-            <a:avLst/>
-          </a:prstGeom>
-          <a:solidFill>
-            <a:srgbClr val="3DD6A0"/>
-          </a:solidFill>
-          <a:ln/>
-        </p:spPr>
-      </p:sp>
-      <p:sp>
-        <p:nvSpPr>
-          <p:cNvPr id="41" name="Text 39"/>
-          <p:cNvSpPr/>
-          <p:nvPr/>
-        </p:nvSpPr>
-        <p:spPr>
-          <a:xfrm>
-            <a:off x="12744450" y="6724650"/>
-            <a:ext cx="4381500" cy="342900"/>
-          </a:xfrm>
-          <a:prstGeom prst="rect">
-            <a:avLst/>
-          </a:prstGeom>
-          <a:noFill/>
-          <a:ln/>
-        </p:spPr>
-        <p:txBody>
-          <a:bodyPr wrap="square" lIns="0" tIns="0" rIns="0" bIns="0" rtlCol="0" anchor="ctr"/>
-          <a:lstStyle/>
-          <a:p>
-            <a:pPr algn="l" indent="0" marL="0">
-              <a:buNone/>
-            </a:pPr>
-            <a:r>
-              <a:rPr lang="en-US" sz="1950" dirty="0" spc="1" kern="0">
-                <a:solidFill>
-                  <a:srgbClr val="3DD6A0"/>
-                </a:solidFill>
-                <a:latin typeface="Be Vietnam Pro SemiBold" pitchFamily="34" charset="0"/>
-                <a:ea typeface="Be Vietnam Pro SemiBold" pitchFamily="34" charset="-122"/>
-                <a:cs typeface="Be Vietnam Pro SemiBold" pitchFamily="34" charset="-120"/>
-              </a:rPr>
-              <a:t>VPN</a:t>
-            </a:r>
-            <a:r>
-              <a:rPr lang="en-US" sz="1950" dirty="0" spc="3" kern="0">
-                <a:solidFill>
-                  <a:srgbClr val="3DD6A0"/>
-                </a:solidFill>
-                <a:latin typeface="Be Vietnam Pro SemiBold" pitchFamily="34" charset="0"/>
-                <a:ea typeface="Be Vietnam Pro SemiBold" pitchFamily="34" charset="-122"/>
-                <a:cs typeface="Be Vietnam Pro SemiBold" pitchFamily="34" charset="-120"/>
-              </a:rPr>
-              <a:t> riêng</a:t>
-            </a:r>
-            <a:r>
-              <a:rPr lang="en-US" sz="1950" dirty="0" spc="-4" kern="0">
-                <a:solidFill>
-                  <a:srgbClr val="3DD6A0"/>
-                </a:solidFill>
-                <a:latin typeface="Be Vietnam Pro SemiBold" pitchFamily="34" charset="0"/>
-                <a:ea typeface="Be Vietnam Pro SemiBold" pitchFamily="34" charset="-122"/>
-                <a:cs typeface="Be Vietnam Pro SemiBold" pitchFamily="34" charset="-120"/>
-              </a:rPr>
-              <a:t> tư</a:t>
-            </a:r>
-            <a:r>
-              <a:rPr lang="en-US" sz="1950" dirty="0" spc="-2" kern="0">
-                <a:solidFill>
-                  <a:srgbClr val="3DD6A0"/>
-                </a:solidFill>
-                <a:latin typeface="Be Vietnam Pro SemiBold" pitchFamily="34" charset="0"/>
-                <a:ea typeface="Be Vietnam Pro SemiBold" pitchFamily="34" charset="-122"/>
-                <a:cs typeface="Be Vietnam Pro SemiBold" pitchFamily="34" charset="-120"/>
-              </a:rPr>
-              <a:t> cá nhân</a:t>
-            </a:r>
-            <a:endParaRPr lang="en-US" sz="1950" dirty="0"/>
-          </a:p>
-        </p:txBody>
-      </p:sp>
-      <p:sp>
-        <p:nvSpPr>
-          <p:cNvPr id="42" name="Shape 40"/>
-          <p:cNvSpPr/>
-          <p:nvPr/>
-        </p:nvSpPr>
-        <p:spPr>
-          <a:xfrm>
-            <a:off x="12344400" y="7181850"/>
-            <a:ext cx="228600" cy="228600"/>
-          </a:xfrm>
-          <a:prstGeom prst="ellipse">
-            <a:avLst/>
-          </a:prstGeom>
-          <a:solidFill>
-            <a:srgbClr val="FF6A4D"/>
-          </a:solidFill>
-          <a:ln/>
-        </p:spPr>
-      </p:sp>
-      <p:sp>
-        <p:nvSpPr>
-          <p:cNvPr id="43" name="Text 41"/>
-          <p:cNvSpPr/>
-          <p:nvPr/>
-        </p:nvSpPr>
-        <p:spPr>
-          <a:xfrm>
-            <a:off x="12744450" y="7124700"/>
-            <a:ext cx="4381500" cy="342900"/>
-          </a:xfrm>
-          <a:prstGeom prst="rect">
-            <a:avLst/>
-          </a:prstGeom>
-          <a:noFill/>
-          <a:ln/>
-        </p:spPr>
-        <p:txBody>
-          <a:bodyPr wrap="square" lIns="0" tIns="0" rIns="0" bIns="0" rtlCol="0" anchor="ctr"/>
-          <a:lstStyle/>
-          <a:p>
-            <a:pPr algn="l" indent="0" marL="0">
-              <a:buNone/>
-            </a:pPr>
-            <a:r>
-              <a:rPr lang="en-US" sz="1950" dirty="0" spc="7" kern="0">
-                <a:solidFill>
-                  <a:srgbClr val="FF6A4D"/>
-                </a:solidFill>
-                <a:latin typeface="Be Vietnam Pro SemiBold" pitchFamily="34" charset="0"/>
-                <a:ea typeface="Be Vietnam Pro SemiBold" pitchFamily="34" charset="-122"/>
-                <a:cs typeface="Be Vietnam Pro SemiBold" pitchFamily="34" charset="-120"/>
-              </a:rPr>
-              <a:t>Giới</a:t>
-            </a:r>
-            <a:r>
-              <a:rPr lang="en-US" sz="1950" dirty="0" spc="-3" kern="0">
-                <a:solidFill>
-                  <a:srgbClr val="FF6A4D"/>
-                </a:solidFill>
-                <a:latin typeface="Be Vietnam Pro SemiBold" pitchFamily="34" charset="0"/>
-                <a:ea typeface="Be Vietnam Pro SemiBold" pitchFamily="34" charset="-122"/>
-                <a:cs typeface="Be Vietnam Pro SemiBold" pitchFamily="34" charset="-120"/>
-              </a:rPr>
-              <a:t> hạn</a:t>
-            </a:r>
-            <a:r>
-              <a:rPr lang="en-US" sz="1950" dirty="0" spc="0" kern="0">
-                <a:solidFill>
-                  <a:srgbClr val="FF6A4D"/>
-                </a:solidFill>
-                <a:latin typeface="Be Vietnam Pro SemiBold" pitchFamily="34" charset="0"/>
-                <a:ea typeface="Be Vietnam Pro SemiBold" pitchFamily="34" charset="-122"/>
-                <a:cs typeface="Be Vietnam Pro SemiBold" pitchFamily="34" charset="-120"/>
-              </a:rPr>
-              <a:t> cần</a:t>
-            </a:r>
-            <a:r>
-              <a:rPr lang="en-US" sz="1950" dirty="0" spc="-3" kern="0">
-                <a:solidFill>
-                  <a:srgbClr val="FF6A4D"/>
-                </a:solidFill>
-                <a:latin typeface="Be Vietnam Pro SemiBold" pitchFamily="34" charset="0"/>
-                <a:ea typeface="Be Vietnam Pro SemiBold" pitchFamily="34" charset="-122"/>
-                <a:cs typeface="Be Vietnam Pro SemiBold" pitchFamily="34" charset="-120"/>
-              </a:rPr>
-              <a:t> nhớ</a:t>
-            </a:r>
-            <a:endParaRPr lang="en-US" sz="1950" dirty="0"/>
-          </a:p>
-        </p:txBody>
-      </p:sp>
-      <p:sp>
-        <p:nvSpPr>
-          <p:cNvPr id="44" name="Text 42"/>
-          <p:cNvSpPr/>
-          <p:nvPr/>
-        </p:nvSpPr>
-        <p:spPr>
-          <a:xfrm>
-            <a:off x="914400" y="7924800"/>
-            <a:ext cx="8572500" cy="285750"/>
+          <p:cNvPr id="36" name="Text 34"/>
+          <p:cNvSpPr/>
+          <p:nvPr/>
+        </p:nvSpPr>
+        <p:spPr>
+          <a:xfrm>
+            <a:off x="914400" y="8267700"/>
+            <a:ext cx="16459200" cy="419100"/>
           </a:xfrm>
           <a:prstGeom prst="rect">
             <a:avLst/>
@@ -5940,52 +5638,195 @@
               <a:buNone/>
             </a:pPr>
             <a:r>
-              <a:rPr lang="en-US" sz="1650" b="1" spc="227" kern="0" dirty="0">
-                <a:solidFill>
-                  <a:srgbClr val="FF6A4D"/>
-                </a:solidFill>
-                <a:latin typeface="Be Vietnam Pro" pitchFamily="34" charset="0"/>
-                <a:ea typeface="Be Vietnam Pro" pitchFamily="34" charset="-122"/>
-                <a:cs typeface="Be Vietnam Pro" pitchFamily="34" charset="-120"/>
-              </a:rPr>
-              <a:t>NGUỒN</a:t>
-            </a:r>
-            <a:r>
-              <a:rPr lang="en-US" sz="1650" b="1" spc="229" kern="0" dirty="0">
-                <a:solidFill>
-                  <a:srgbClr val="FF6A4D"/>
-                </a:solidFill>
-                <a:latin typeface="Be Vietnam Pro" pitchFamily="34" charset="0"/>
-                <a:ea typeface="Be Vietnam Pro" pitchFamily="34" charset="-122"/>
-                <a:cs typeface="Be Vietnam Pro" pitchFamily="34" charset="-120"/>
-              </a:rPr>
-              <a:t> ĐỐI</a:t>
-            </a:r>
-            <a:r>
-              <a:rPr lang="en-US" sz="1650" b="1" spc="227" kern="0" dirty="0">
-                <a:solidFill>
-                  <a:srgbClr val="FF6A4D"/>
-                </a:solidFill>
-                <a:latin typeface="Be Vietnam Pro" pitchFamily="34" charset="0"/>
-                <a:ea typeface="Be Vietnam Pro" pitchFamily="34" charset="-122"/>
-                <a:cs typeface="Be Vietnam Pro" pitchFamily="34" charset="-120"/>
-              </a:rPr>
-              <a:t> CHIẾU</a:t>
-            </a:r>
-            <a:endParaRPr lang="en-US" sz="1650" dirty="0"/>
+              <a:rPr lang="en-US" sz="2100" dirty="0" spc="-6" kern="0">
+                <a:solidFill>
+                  <a:srgbClr val="F3EEE3"/>
+                </a:solidFill>
+                <a:latin typeface="Be Vietnam Pro" pitchFamily="34" charset="0"/>
+                <a:ea typeface="Be Vietnam Pro" pitchFamily="34" charset="-122"/>
+                <a:cs typeface="Be Vietnam Pro" pitchFamily="34" charset="-120"/>
+              </a:rPr>
+              <a:t>ByteByteGo</a:t>
+            </a:r>
+            <a:r>
+              <a:rPr lang="en-US" sz="2100" dirty="0" spc="-7" kern="0">
+                <a:solidFill>
+                  <a:srgbClr val="F3EEE3"/>
+                </a:solidFill>
+                <a:latin typeface="Be Vietnam Pro" pitchFamily="34" charset="0"/>
+                <a:ea typeface="Be Vietnam Pro" pitchFamily="34" charset="-122"/>
+                <a:cs typeface="Be Vietnam Pro" pitchFamily="34" charset="-120"/>
+              </a:rPr>
+              <a:t> system-design-101 ·</a:t>
+            </a:r>
+            <a:r>
+              <a:rPr lang="en-US" sz="2100" dirty="0" spc="-3" kern="0">
+                <a:solidFill>
+                  <a:srgbClr val="F3EEE3"/>
+                </a:solidFill>
+                <a:latin typeface="Be Vietnam Pro" pitchFamily="34" charset="0"/>
+                <a:ea typeface="Be Vietnam Pro" pitchFamily="34" charset="-122"/>
+                <a:cs typeface="Be Vietnam Pro" pitchFamily="34" charset="-120"/>
+              </a:rPr>
+              <a:t> OpenVPN</a:t>
+            </a:r>
+            <a:r>
+              <a:rPr lang="en-US" sz="2100" dirty="0" spc="-5" kern="0">
+                <a:solidFill>
+                  <a:srgbClr val="F3EEE3"/>
+                </a:solidFill>
+                <a:latin typeface="Be Vietnam Pro" pitchFamily="34" charset="0"/>
+                <a:ea typeface="Be Vietnam Pro" pitchFamily="34" charset="-122"/>
+                <a:cs typeface="Be Vietnam Pro" pitchFamily="34" charset="-120"/>
+              </a:rPr>
+              <a:t> ·</a:t>
+            </a:r>
+            <a:r>
+              <a:rPr lang="en-US" sz="2100" dirty="0" spc="-19" kern="0">
+                <a:solidFill>
+                  <a:srgbClr val="F3EEE3"/>
+                </a:solidFill>
+                <a:latin typeface="Be Vietnam Pro" pitchFamily="34" charset="0"/>
+                <a:ea typeface="Be Vietnam Pro" pitchFamily="34" charset="-122"/>
+                <a:cs typeface="Be Vietnam Pro" pitchFamily="34" charset="-120"/>
+              </a:rPr>
+              <a:t> WireGuard</a:t>
+            </a:r>
+            <a:r>
+              <a:rPr lang="en-US" sz="2100" dirty="0" spc="-3" kern="0">
+                <a:solidFill>
+                  <a:srgbClr val="F3EEE3"/>
+                </a:solidFill>
+                <a:latin typeface="Be Vietnam Pro" pitchFamily="34" charset="0"/>
+                <a:ea typeface="Be Vietnam Pro" pitchFamily="34" charset="-122"/>
+                <a:cs typeface="Be Vietnam Pro" pitchFamily="34" charset="-120"/>
+              </a:rPr>
+              <a:t> ·</a:t>
+            </a:r>
+            <a:r>
+              <a:rPr lang="en-US" sz="2100" dirty="0" spc="-1" kern="0">
+                <a:solidFill>
+                  <a:srgbClr val="F3EEE3"/>
+                </a:solidFill>
+                <a:latin typeface="Be Vietnam Pro" pitchFamily="34" charset="0"/>
+                <a:ea typeface="Be Vietnam Pro" pitchFamily="34" charset="-122"/>
+                <a:cs typeface="Be Vietnam Pro" pitchFamily="34" charset="-120"/>
+              </a:rPr>
+              <a:t> nhân</a:t>
+            </a:r>
+            <a:r>
+              <a:rPr lang="en-US" sz="2100" dirty="0" spc="1" kern="0">
+                <a:solidFill>
+                  <a:srgbClr val="F3EEE3"/>
+                </a:solidFill>
+                <a:latin typeface="Be Vietnam Pro" pitchFamily="34" charset="0"/>
+                <a:ea typeface="Be Vietnam Pro" pitchFamily="34" charset="-122"/>
+                <a:cs typeface="Be Vietnam Pro" pitchFamily="34" charset="-120"/>
+              </a:rPr>
+              <a:t> Linux</a:t>
+            </a:r>
+            <a:r>
+              <a:rPr lang="en-US" sz="2100" dirty="0" spc="-5" kern="0">
+                <a:solidFill>
+                  <a:srgbClr val="F3EEE3"/>
+                </a:solidFill>
+                <a:latin typeface="Be Vietnam Pro" pitchFamily="34" charset="0"/>
+                <a:ea typeface="Be Vietnam Pro" pitchFamily="34" charset="-122"/>
+                <a:cs typeface="Be Vietnam Pro" pitchFamily="34" charset="-120"/>
+              </a:rPr>
+              <a:t> ·</a:t>
+            </a:r>
+            <a:r>
+              <a:rPr lang="en-US" sz="2100" dirty="0" spc="-13" kern="0">
+                <a:solidFill>
+                  <a:srgbClr val="F3EEE3"/>
+                </a:solidFill>
+                <a:latin typeface="Be Vietnam Pro" pitchFamily="34" charset="0"/>
+                <a:ea typeface="Be Vietnam Pro" pitchFamily="34" charset="-122"/>
+                <a:cs typeface="Be Vietnam Pro" pitchFamily="34" charset="-120"/>
+              </a:rPr>
+              <a:t> strongSwan</a:t>
+            </a:r>
+            <a:r>
+              <a:rPr lang="en-US" sz="2100" dirty="0" spc="-6" kern="0">
+                <a:solidFill>
+                  <a:srgbClr val="F3EEE3"/>
+                </a:solidFill>
+                <a:latin typeface="Be Vietnam Pro" pitchFamily="34" charset="0"/>
+                <a:ea typeface="Be Vietnam Pro" pitchFamily="34" charset="-122"/>
+                <a:cs typeface="Be Vietnam Pro" pitchFamily="34" charset="-120"/>
+              </a:rPr>
+              <a:t> ·</a:t>
+            </a:r>
+            <a:r>
+              <a:rPr lang="en-US" sz="2100" dirty="0" spc="1" kern="0">
+                <a:solidFill>
+                  <a:srgbClr val="F3EEE3"/>
+                </a:solidFill>
+                <a:latin typeface="Be Vietnam Pro" pitchFamily="34" charset="0"/>
+                <a:ea typeface="Be Vietnam Pro" pitchFamily="34" charset="-122"/>
+                <a:cs typeface="Be Vietnam Pro" pitchFamily="34" charset="-120"/>
+              </a:rPr>
+              <a:t> MDN</a:t>
+            </a:r>
+            <a:r>
+              <a:rPr lang="en-US" sz="2100" dirty="0" spc="-4" kern="0">
+                <a:solidFill>
+                  <a:srgbClr val="F3EEE3"/>
+                </a:solidFill>
+                <a:latin typeface="Be Vietnam Pro" pitchFamily="34" charset="0"/>
+                <a:ea typeface="Be Vietnam Pro" pitchFamily="34" charset="-122"/>
+                <a:cs typeface="Be Vietnam Pro" pitchFamily="34" charset="-120"/>
+              </a:rPr>
+              <a:t> ·</a:t>
+            </a:r>
+            <a:r>
+              <a:rPr lang="en-US" sz="2100" dirty="0" spc="-48" kern="0">
+                <a:solidFill>
+                  <a:srgbClr val="F3EEE3"/>
+                </a:solidFill>
+                <a:latin typeface="Be Vietnam Pro" pitchFamily="34" charset="0"/>
+                <a:ea typeface="Be Vietnam Pro" pitchFamily="34" charset="-122"/>
+                <a:cs typeface="Be Vietnam Pro" pitchFamily="34" charset="-120"/>
+              </a:rPr>
+              <a:t> OWASP</a:t>
+            </a:r>
+            <a:r>
+              <a:rPr lang="en-US" sz="2100" dirty="0" spc="-20" kern="0">
+                <a:solidFill>
+                  <a:srgbClr val="F3EEE3"/>
+                </a:solidFill>
+                <a:latin typeface="Be Vietnam Pro" pitchFamily="34" charset="0"/>
+                <a:ea typeface="Be Vietnam Pro" pitchFamily="34" charset="-122"/>
+                <a:cs typeface="Be Vietnam Pro" pitchFamily="34" charset="-120"/>
+              </a:rPr>
+              <a:t> Zero</a:t>
+            </a:r>
+            <a:r>
+              <a:rPr lang="en-US" sz="2100" dirty="0" spc="-28" kern="0">
+                <a:solidFill>
+                  <a:srgbClr val="F3EEE3"/>
+                </a:solidFill>
+                <a:latin typeface="Be Vietnam Pro" pitchFamily="34" charset="0"/>
+                <a:ea typeface="Be Vietnam Pro" pitchFamily="34" charset="-122"/>
+                <a:cs typeface="Be Vietnam Pro" pitchFamily="34" charset="-120"/>
+              </a:rPr>
+              <a:t> Trust</a:t>
+            </a:r>
+            <a:endParaRPr lang="en-US" sz="2100" dirty="0"/>
           </a:p>
         </p:txBody>
       </p:sp>
       <p:sp>
         <p:nvSpPr>
-          <p:cNvPr id="45" name="Text 43"/>
-          <p:cNvSpPr/>
-          <p:nvPr/>
-        </p:nvSpPr>
-        <p:spPr>
-          <a:xfrm>
-            <a:off x="914400" y="8267700"/>
-            <a:ext cx="16459200" cy="419100"/>
+          <p:cNvPr id="37" name="Text 35"/>
+          <p:cNvSpPr/>
+          <p:nvPr/>
+        </p:nvSpPr>
+        <p:spPr>
+          <a:xfrm>
+            <a:off x="914400" y="8763000"/>
+            <a:ext cx="16459200" cy="323850"/>
           </a:xfrm>
           <a:prstGeom prst="rect">
             <a:avLst/>
@@ -6001,210 +5842,6 @@
               <a:buNone/>
             </a:pPr>
             <a:r>
-              <a:rPr lang="en-US" sz="2100" dirty="0" spc="-6" kern="0">
-                <a:solidFill>
-                  <a:srgbClr val="F3EEE3"/>
-                </a:solidFill>
-                <a:latin typeface="Be Vietnam Pro" pitchFamily="34" charset="0"/>
-                <a:ea typeface="Be Vietnam Pro" pitchFamily="34" charset="-122"/>
-                <a:cs typeface="Be Vietnam Pro" pitchFamily="34" charset="-120"/>
-              </a:rPr>
-              <a:t>ByteByteGo</a:t>
-            </a:r>
-            <a:r>
-              <a:rPr lang="en-US" sz="2100" dirty="0" spc="-7" kern="0">
-                <a:solidFill>
-                  <a:srgbClr val="F3EEE3"/>
-                </a:solidFill>
-                <a:latin typeface="Be Vietnam Pro" pitchFamily="34" charset="0"/>
-                <a:ea typeface="Be Vietnam Pro" pitchFamily="34" charset="-122"/>
-                <a:cs typeface="Be Vietnam Pro" pitchFamily="34" charset="-120"/>
-              </a:rPr>
-              <a:t> system-design-101 ·</a:t>
-            </a:r>
-            <a:r>
-              <a:rPr lang="en-US" sz="2100" dirty="0" spc="-3" kern="0">
-                <a:solidFill>
-                  <a:srgbClr val="F3EEE3"/>
-                </a:solidFill>
-                <a:latin typeface="Be Vietnam Pro" pitchFamily="34" charset="0"/>
-                <a:ea typeface="Be Vietnam Pro" pitchFamily="34" charset="-122"/>
-                <a:cs typeface="Be Vietnam Pro" pitchFamily="34" charset="-120"/>
-              </a:rPr>
-              <a:t> OpenVPN</a:t>
-            </a:r>
-            <a:r>
-              <a:rPr lang="en-US" sz="2100" dirty="0" spc="-5" kern="0">
-                <a:solidFill>
-                  <a:srgbClr val="F3EEE3"/>
-                </a:solidFill>
-                <a:latin typeface="Be Vietnam Pro" pitchFamily="34" charset="0"/>
-                <a:ea typeface="Be Vietnam Pro" pitchFamily="34" charset="-122"/>
-                <a:cs typeface="Be Vietnam Pro" pitchFamily="34" charset="-120"/>
-              </a:rPr>
-              <a:t> ·</a:t>
-            </a:r>
-            <a:r>
-              <a:rPr lang="en-US" sz="2100" dirty="0" spc="-19" kern="0">
-                <a:solidFill>
-                  <a:srgbClr val="F3EEE3"/>
-                </a:solidFill>
-                <a:latin typeface="Be Vietnam Pro" pitchFamily="34" charset="0"/>
-                <a:ea typeface="Be Vietnam Pro" pitchFamily="34" charset="-122"/>
-                <a:cs typeface="Be Vietnam Pro" pitchFamily="34" charset="-120"/>
-              </a:rPr>
-              <a:t> WireGuard</a:t>
-            </a:r>
-            <a:r>
-              <a:rPr lang="en-US" sz="2100" dirty="0" spc="-3" kern="0">
-                <a:solidFill>
-                  <a:srgbClr val="F3EEE3"/>
-                </a:solidFill>
-                <a:latin typeface="Be Vietnam Pro" pitchFamily="34" charset="0"/>
-                <a:ea typeface="Be Vietnam Pro" pitchFamily="34" charset="-122"/>
-                <a:cs typeface="Be Vietnam Pro" pitchFamily="34" charset="-120"/>
-              </a:rPr>
-              <a:t> ·</a:t>
-            </a:r>
-            <a:r>
-              <a:rPr lang="en-US" sz="2100" dirty="0" spc="-1" kern="0">
-                <a:solidFill>
-                  <a:srgbClr val="F3EEE3"/>
-                </a:solidFill>
-                <a:latin typeface="Be Vietnam Pro" pitchFamily="34" charset="0"/>
-                <a:ea typeface="Be Vietnam Pro" pitchFamily="34" charset="-122"/>
-                <a:cs typeface="Be Vietnam Pro" pitchFamily="34" charset="-120"/>
-              </a:rPr>
-              <a:t> nhân</a:t>
-            </a:r>
-            <a:r>
-              <a:rPr lang="en-US" sz="2100" dirty="0" spc="1" kern="0">
-                <a:solidFill>
-                  <a:srgbClr val="F3EEE3"/>
-                </a:solidFill>
-                <a:latin typeface="Be Vietnam Pro" pitchFamily="34" charset="0"/>
-                <a:ea typeface="Be Vietnam Pro" pitchFamily="34" charset="-122"/>
-                <a:cs typeface="Be Vietnam Pro" pitchFamily="34" charset="-120"/>
-              </a:rPr>
-              <a:t> Linux</a:t>
-            </a:r>
-            <a:r>
-              <a:rPr lang="en-US" sz="2100" dirty="0" spc="-5" kern="0">
-                <a:solidFill>
-                  <a:srgbClr val="F3EEE3"/>
-                </a:solidFill>
-                <a:latin typeface="Be Vietnam Pro" pitchFamily="34" charset="0"/>
-                <a:ea typeface="Be Vietnam Pro" pitchFamily="34" charset="-122"/>
-                <a:cs typeface="Be Vietnam Pro" pitchFamily="34" charset="-120"/>
-              </a:rPr>
-              <a:t> ·</a:t>
-            </a:r>
-            <a:r>
-              <a:rPr lang="en-US" sz="2100" dirty="0" spc="-13" kern="0">
-                <a:solidFill>
-                  <a:srgbClr val="F3EEE3"/>
-                </a:solidFill>
-                <a:latin typeface="Be Vietnam Pro" pitchFamily="34" charset="0"/>
-                <a:ea typeface="Be Vietnam Pro" pitchFamily="34" charset="-122"/>
-                <a:cs typeface="Be Vietnam Pro" pitchFamily="34" charset="-120"/>
-              </a:rPr>
-              <a:t> strongSwan</a:t>
-            </a:r>
-            <a:r>
-              <a:rPr lang="en-US" sz="2100" dirty="0" spc="-6" kern="0">
-                <a:solidFill>
-                  <a:srgbClr val="F3EEE3"/>
-                </a:solidFill>
-                <a:latin typeface="Be Vietnam Pro" pitchFamily="34" charset="0"/>
-                <a:ea typeface="Be Vietnam Pro" pitchFamily="34" charset="-122"/>
-                <a:cs typeface="Be Vietnam Pro" pitchFamily="34" charset="-120"/>
-              </a:rPr>
-              <a:t> ·</a:t>
-            </a:r>
-            <a:r>
-              <a:rPr lang="en-US" sz="2100" dirty="0" spc="1" kern="0">
-                <a:solidFill>
-                  <a:srgbClr val="F3EEE3"/>
-                </a:solidFill>
-                <a:latin typeface="Be Vietnam Pro" pitchFamily="34" charset="0"/>
-                <a:ea typeface="Be Vietnam Pro" pitchFamily="34" charset="-122"/>
-                <a:cs typeface="Be Vietnam Pro" pitchFamily="34" charset="-120"/>
-              </a:rPr>
-              <a:t> MDN</a:t>
-            </a:r>
-            <a:r>
-              <a:rPr lang="en-US" sz="2100" dirty="0" spc="-4" kern="0">
-                <a:solidFill>
-                  <a:srgbClr val="F3EEE3"/>
-                </a:solidFill>
-                <a:latin typeface="Be Vietnam Pro" pitchFamily="34" charset="0"/>
-                <a:ea typeface="Be Vietnam Pro" pitchFamily="34" charset="-122"/>
-                <a:cs typeface="Be Vietnam Pro" pitchFamily="34" charset="-120"/>
-              </a:rPr>
-              <a:t> ·</a:t>
-            </a:r>
-            <a:r>
-              <a:rPr lang="en-US" sz="2100" dirty="0" spc="-48" kern="0">
-                <a:solidFill>
-                  <a:srgbClr val="F3EEE3"/>
-                </a:solidFill>
-                <a:latin typeface="Be Vietnam Pro" pitchFamily="34" charset="0"/>
-                <a:ea typeface="Be Vietnam Pro" pitchFamily="34" charset="-122"/>
-                <a:cs typeface="Be Vietnam Pro" pitchFamily="34" charset="-120"/>
-              </a:rPr>
-              <a:t> OWASP</a:t>
-            </a:r>
-            <a:r>
-              <a:rPr lang="en-US" sz="2100" dirty="0" spc="-20" kern="0">
-                <a:solidFill>
-                  <a:srgbClr val="F3EEE3"/>
-                </a:solidFill>
-                <a:latin typeface="Be Vietnam Pro" pitchFamily="34" charset="0"/>
-                <a:ea typeface="Be Vietnam Pro" pitchFamily="34" charset="-122"/>
-                <a:cs typeface="Be Vietnam Pro" pitchFamily="34" charset="-120"/>
-              </a:rPr>
-              <a:t> Zero</a:t>
-            </a:r>
-            <a:r>
-              <a:rPr lang="en-US" sz="2100" dirty="0" spc="-28" kern="0">
-                <a:solidFill>
-                  <a:srgbClr val="F3EEE3"/>
-                </a:solidFill>
-                <a:latin typeface="Be Vietnam Pro" pitchFamily="34" charset="0"/>
-                <a:ea typeface="Be Vietnam Pro" pitchFamily="34" charset="-122"/>
-                <a:cs typeface="Be Vietnam Pro" pitchFamily="34" charset="-120"/>
-              </a:rPr>
-              <a:t> Trust</a:t>
-            </a:r>
-            <a:endParaRPr lang="en-US" sz="2100" dirty="0"/>
-          </a:p>
-        </p:txBody>
-      </p:sp>
-      <p:sp>
-        <p:nvSpPr>
-          <p:cNvPr id="46" name="Text 44"/>
-          <p:cNvSpPr/>
-          <p:nvPr/>
-        </p:nvSpPr>
-        <p:spPr>
-          <a:xfrm>
-            <a:off x="914400" y="8763000"/>
-            <a:ext cx="16459200" cy="323850"/>
-          </a:xfrm>
-          <a:prstGeom prst="rect">
-            <a:avLst/>
-          </a:prstGeom>
-          <a:noFill/>
-          <a:ln/>
-        </p:spPr>
-        <p:txBody>
-          <a:bodyPr wrap="square" lIns="0" tIns="0" rIns="0" bIns="0" rtlCol="0" anchor="t"/>
-          <a:lstStyle/>
-          <a:p>
-            <a:pPr algn="l" indent="0" marL="0">
-              <a:buNone/>
-            </a:pPr>
-            <a:r>
               <a:rPr lang="en-US" sz="1650" dirty="0" spc="1" kern="0">
                 <a:solidFill>
                   <a:srgbClr val="9A98A0"/>
@@ -6320,7 +5957,7 @@
       </p:sp>
       <p:sp>
         <p:nvSpPr>
-          <p:cNvPr id="47" name="Connector line-1792363576145-893101561"/>
+          <p:cNvPr id="38" name="Connector line-1792363576145-893101561"/>
           <p:cNvSpPr/>
           <p:nvPr/>
         </p:nvSpPr>
@@ -6347,7 +5984,7 @@
       </p:sp>
       <p:sp>
         <p:nvSpPr>
-          <p:cNvPr id="48" name="Shape 46"/>
+          <p:cNvPr id="39" name="Shape 37"/>
           <p:cNvSpPr/>
           <p:nvPr/>
         </p:nvSpPr>
@@ -6367,7 +6004,7 @@
       </p:sp>
       <p:sp>
         <p:nvSpPr>
-          <p:cNvPr id="49" name="Shape 47"/>
+          <p:cNvPr id="40" name="Shape 38"/>
           <p:cNvSpPr/>
           <p:nvPr/>
         </p:nvSpPr>
@@ -6387,7 +6024,7 @@
       </p:sp>
       <p:sp>
         <p:nvSpPr>
-          <p:cNvPr id="50" name="Shape 48"/>
+          <p:cNvPr id="41" name="Shape 39"/>
           <p:cNvSpPr/>
           <p:nvPr/>
         </p:nvSpPr>
@@ -6407,7 +6044,7 @@
       </p:sp>
       <p:sp>
         <p:nvSpPr>
-          <p:cNvPr id="51" name="Shape 49"/>
+          <p:cNvPr id="42" name="Shape 40"/>
           <p:cNvSpPr/>
           <p:nvPr/>
         </p:nvSpPr>
@@ -6427,7 +6064,7 @@
       </p:sp>
       <p:sp>
         <p:nvSpPr>
-          <p:cNvPr id="52" name="Shape 50"/>
+          <p:cNvPr id="43" name="Shape 41"/>
           <p:cNvSpPr/>
           <p:nvPr/>
         </p:nvSpPr>
@@ -6447,7 +6084,7 @@
       </p:sp>
       <p:sp>
         <p:nvSpPr>
-          <p:cNvPr id="53" name="Shape 51"/>
+          <p:cNvPr id="44" name="Shape 42"/>
           <p:cNvSpPr/>
           <p:nvPr/>
         </p:nvSpPr>
@@ -6467,7 +6104,7 @@
       </p:sp>
       <p:sp>
         <p:nvSpPr>
-          <p:cNvPr id="54" name="Shape 52"/>
+          <p:cNvPr id="45" name="Shape 43"/>
           <p:cNvSpPr/>
           <p:nvPr/>
         </p:nvSpPr>
@@ -6487,7 +6124,7 @@
       </p:sp>
       <p:sp>
         <p:nvSpPr>
-          <p:cNvPr id="55" name="Shape 53"/>
+          <p:cNvPr id="46" name="Shape 44"/>
           <p:cNvSpPr/>
           <p:nvPr/>
         </p:nvSpPr>
@@ -6507,7 +6144,7 @@
       </p:sp>
       <p:sp>
         <p:nvSpPr>
-          <p:cNvPr id="56" name="Shape 54"/>
+          <p:cNvPr id="47" name="Shape 45"/>
           <p:cNvSpPr/>
           <p:nvPr/>
         </p:nvSpPr>
@@ -6527,7 +6164,7 @@
       </p:sp>
       <p:sp>
         <p:nvSpPr>
-          <p:cNvPr id="57" name="Shape 55"/>
+          <p:cNvPr id="48" name="Shape 46"/>
           <p:cNvSpPr/>
           <p:nvPr/>
         </p:nvSpPr>
@@ -6547,7 +6184,7 @@
       </p:sp>
       <p:sp>
         <p:nvSpPr>
-          <p:cNvPr id="58" name="Text 56"/>
+          <p:cNvPr id="49" name="Text 47"/>
           <p:cNvSpPr/>
           <p:nvPr/>
         </p:nvSpPr>
@@ -6663,7 +6300,364 @@
       </p:sp>
       <p:sp>
         <p:nvSpPr>
-          <p:cNvPr id="59" name="Shape 57"/>
+          <p:cNvPr id="50" name="Connector line-1792378797765-17984541"/>
+          <p:cNvSpPr/>
+          <p:nvPr/>
+        </p:nvSpPr>
+        <p:spPr>
+          <a:xfrm>
+            <a:off x="12553950" y="5562600"/>
+            <a:ext cx="4533900" cy="0"/>
+          </a:xfrm>
+          <a:prstGeom prst="line">
+            <a:avLst/>
+          </a:prstGeom>
+          <a:noFill/>
+          <a:ln w="28575">
+            <a:solidFill>
+              <a:srgbClr val="2A2D38"/>
+            </a:solidFill>
+            <a:prstDash val="solid"/>
+            <a:headEnd type="none"/>
+            <a:tailEnd type="none"/>
+          </a:ln>
+        </p:spPr>
+      </p:sp>
+      <p:sp>
+        <p:nvSpPr>
+          <p:cNvPr id="51" name="Shape 49"/>
+          <p:cNvSpPr/>
+          <p:nvPr/>
+        </p:nvSpPr>
+        <p:spPr>
+          <a:xfrm>
+            <a:off x="12296775" y="5476875"/>
+            <a:ext cx="171450" cy="171450"/>
+          </a:xfrm>
+          <a:prstGeom prst="ellipse">
+            <a:avLst/>
+          </a:prstGeom>
+          <a:solidFill>
+            <a:srgbClr val="1E212B"/>
+          </a:solidFill>
+          <a:ln w="28575">
+            <a:solidFill>
+              <a:srgbClr val="9A98A0"/>
+            </a:solidFill>
+            <a:prstDash val="solid"/>
+          </a:ln>
+        </p:spPr>
+      </p:sp>
+      <p:sp>
+        <p:nvSpPr>
+          <p:cNvPr id="52" name="Text 50"/>
+          <p:cNvSpPr/>
+          <p:nvPr/>
+        </p:nvSpPr>
+        <p:spPr>
+          <a:xfrm>
+            <a:off x="12325350" y="5781675"/>
+            <a:ext cx="4762500" cy="666750"/>
+          </a:xfrm>
+          <a:prstGeom prst="rect">
+            <a:avLst/>
+          </a:prstGeom>
+          <a:noFill/>
+          <a:ln/>
+        </p:spPr>
+        <p:txBody>
+          <a:bodyPr wrap="square" lIns="0" tIns="0" rIns="0" bIns="0" rtlCol="0" anchor="t"/>
+          <a:lstStyle/>
+          <a:p>
+            <a:pPr algn="l" indent="0" marL="0">
+              <a:buNone/>
+            </a:pPr>
+            <a:r>
+              <a:rPr lang="en-US" sz="3900" dirty="0" spc="-33" kern="0">
+                <a:solidFill>
+                  <a:srgbClr val="F3EEE3"/>
+                </a:solidFill>
+                <a:latin typeface="Bricolage Grotesque ExtraBold" pitchFamily="34" charset="0"/>
+                <a:ea typeface="Bricolage Grotesque ExtraBold" pitchFamily="34" charset="-122"/>
+                <a:cs typeface="Bricolage Grotesque ExtraBold" pitchFamily="34" charset="-120"/>
+              </a:rPr>
+              <a:t>IPv4</a:t>
+            </a:r>
+            <a:r>
+              <a:rPr lang="en-US" sz="3900" dirty="0" spc="1" kern="0">
+                <a:solidFill>
+                  <a:srgbClr val="F3EEE3"/>
+                </a:solidFill>
+                <a:latin typeface="Bricolage Grotesque ExtraBold" pitchFamily="34" charset="0"/>
+                <a:ea typeface="Bricolage Grotesque ExtraBold" pitchFamily="34" charset="-122"/>
+                <a:cs typeface="Bricolage Grotesque ExtraBold" pitchFamily="34" charset="-120"/>
+              </a:rPr>
+              <a:t> ·</a:t>
+            </a:r>
+            <a:r>
+              <a:rPr lang="en-US" sz="3900" dirty="0" spc="-5" kern="0">
+                <a:solidFill>
+                  <a:srgbClr val="F3EEE3"/>
+                </a:solidFill>
+                <a:latin typeface="Bricolage Grotesque ExtraBold" pitchFamily="34" charset="0"/>
+                <a:ea typeface="Bricolage Grotesque ExtraBold" pitchFamily="34" charset="-122"/>
+                <a:cs typeface="Bricolage Grotesque ExtraBold" pitchFamily="34" charset="-120"/>
+              </a:rPr>
+              <a:t> IPv6</a:t>
+            </a:r>
+            <a:endParaRPr lang="en-US" sz="3900" dirty="0"/>
+          </a:p>
+        </p:txBody>
+      </p:sp>
+      <p:sp>
+        <p:nvSpPr>
+          <p:cNvPr id="53" name="Text 51"/>
+          <p:cNvSpPr/>
+          <p:nvPr/>
+        </p:nvSpPr>
+        <p:spPr>
+          <a:xfrm>
+            <a:off x="12325350" y="6448425"/>
+            <a:ext cx="4762500" cy="323850"/>
+          </a:xfrm>
+          <a:prstGeom prst="rect">
+            <a:avLst/>
+          </a:prstGeom>
+          <a:noFill/>
+          <a:ln/>
+        </p:spPr>
+        <p:txBody>
+          <a:bodyPr wrap="square" lIns="0" tIns="0" rIns="0" bIns="0" rtlCol="0" anchor="ctr"/>
+          <a:lstStyle/>
+          <a:p>
+            <a:pPr algn="l" indent="0" marL="0">
+              <a:buNone/>
+            </a:pPr>
+            <a:r>
+              <a:rPr lang="en-US" sz="1650" dirty="0" spc="-10" kern="0">
+                <a:solidFill>
+                  <a:srgbClr val="9A98A0"/>
+                </a:solidFill>
+                <a:latin typeface="Be Vietnam Pro" pitchFamily="34" charset="0"/>
+                <a:ea typeface="Be Vietnam Pro" pitchFamily="34" charset="-122"/>
+                <a:cs typeface="Be Vietnam Pro" pitchFamily="34" charset="-120"/>
+              </a:rPr>
+              <a:t>Internet</a:t>
+            </a:r>
+            <a:r>
+              <a:rPr lang="en-US" sz="1650" dirty="0" spc="-15" kern="0">
+                <a:solidFill>
+                  <a:srgbClr val="9A98A0"/>
+                </a:solidFill>
+                <a:latin typeface="Be Vietnam Pro" pitchFamily="34" charset="0"/>
+                <a:ea typeface="Be Vietnam Pro" pitchFamily="34" charset="-122"/>
+                <a:cs typeface="Be Vietnam Pro" pitchFamily="34" charset="-120"/>
+              </a:rPr>
+              <a:t> Protocol</a:t>
+            </a:r>
+            <a:r>
+              <a:rPr lang="en-US" sz="1650" dirty="0" spc="-4" kern="0">
+                <a:solidFill>
+                  <a:srgbClr val="9A98A0"/>
+                </a:solidFill>
+                <a:latin typeface="Be Vietnam Pro" pitchFamily="34" charset="0"/>
+                <a:ea typeface="Be Vietnam Pro" pitchFamily="34" charset="-122"/>
+                <a:cs typeface="Be Vietnam Pro" pitchFamily="34" charset="-120"/>
+              </a:rPr>
+              <a:t> version</a:t>
+            </a:r>
+            <a:r>
+              <a:rPr lang="en-US" sz="1650" dirty="0" spc="-1" kern="0">
+                <a:solidFill>
+                  <a:srgbClr val="9A98A0"/>
+                </a:solidFill>
+                <a:latin typeface="Be Vietnam Pro" pitchFamily="34" charset="0"/>
+                <a:ea typeface="Be Vietnam Pro" pitchFamily="34" charset="-122"/>
+                <a:cs typeface="Be Vietnam Pro" pitchFamily="34" charset="-120"/>
+              </a:rPr>
+              <a:t> 4</a:t>
+            </a:r>
+            <a:r>
+              <a:rPr lang="en-US" sz="1650" dirty="0" spc="4" kern="0">
+                <a:solidFill>
+                  <a:srgbClr val="9A98A0"/>
+                </a:solidFill>
+                <a:latin typeface="Be Vietnam Pro" pitchFamily="34" charset="0"/>
+                <a:ea typeface="Be Vietnam Pro" pitchFamily="34" charset="-122"/>
+                <a:cs typeface="Be Vietnam Pro" pitchFamily="34" charset="-120"/>
+              </a:rPr>
+              <a:t> /</a:t>
+            </a:r>
+            <a:r>
+              <a:rPr lang="en-US" sz="1650" dirty="0" spc="-5" kern="0">
+                <a:solidFill>
+                  <a:srgbClr val="9A98A0"/>
+                </a:solidFill>
+                <a:latin typeface="Be Vietnam Pro" pitchFamily="34" charset="0"/>
+                <a:ea typeface="Be Vietnam Pro" pitchFamily="34" charset="-122"/>
+                <a:cs typeface="Be Vietnam Pro" pitchFamily="34" charset="-120"/>
+              </a:rPr>
+              <a:t> version</a:t>
+            </a:r>
+            <a:r>
+              <a:rPr lang="en-US" sz="1650" dirty="0" spc="2" kern="0">
+                <a:solidFill>
+                  <a:srgbClr val="9A98A0"/>
+                </a:solidFill>
+                <a:latin typeface="Be Vietnam Pro" pitchFamily="34" charset="0"/>
+                <a:ea typeface="Be Vietnam Pro" pitchFamily="34" charset="-122"/>
+                <a:cs typeface="Be Vietnam Pro" pitchFamily="34" charset="-120"/>
+              </a:rPr>
+              <a:t> 6</a:t>
+            </a:r>
+            <a:endParaRPr lang="en-US" sz="1650" dirty="0"/>
+          </a:p>
+        </p:txBody>
+      </p:sp>
+      <p:sp>
+        <p:nvSpPr>
+          <p:cNvPr id="54" name="Text 52"/>
+          <p:cNvSpPr/>
+          <p:nvPr/>
+        </p:nvSpPr>
+        <p:spPr>
+          <a:xfrm>
+            <a:off x="12325350" y="6858000"/>
+            <a:ext cx="4762500" cy="723900"/>
+          </a:xfrm>
+          <a:prstGeom prst="rect">
+            <a:avLst/>
+          </a:prstGeom>
+          <a:noFill/>
+          <a:ln/>
+        </p:spPr>
+        <p:txBody>
+          <a:bodyPr wrap="square" lIns="0" tIns="7414" rIns="0" bIns="-7414" rtlCol="0" anchor="t"/>
+          <a:lstStyle/>
+          <a:p>
+            <a:pPr algn="l" indent="0" marL="0">
+              <a:lnSpc>
+                <a:spcPts val="2633"/>
+              </a:lnSpc>
+              <a:buNone/>
+            </a:pPr>
+            <a:r>
+              <a:rPr lang="en-US" sz="1950" dirty="0" spc="0" kern="0">
+                <a:solidFill>
+                  <a:srgbClr val="D8D3C4"/>
+                </a:solidFill>
+                <a:latin typeface="Be Vietnam Pro" pitchFamily="34" charset="0"/>
+                <a:ea typeface="Be Vietnam Pro" pitchFamily="34" charset="-122"/>
+                <a:cs typeface="Be Vietnam Pro" pitchFamily="34" charset="-120"/>
+              </a:rPr>
+              <a:t>Hai kiểu</a:t>
+            </a:r>
+            <a:r>
+              <a:rPr lang="en-US" sz="1950" dirty="0" spc="20" kern="0">
+                <a:solidFill>
+                  <a:srgbClr val="D8D3C4"/>
+                </a:solidFill>
+                <a:latin typeface="Be Vietnam Pro" pitchFamily="34" charset="0"/>
+                <a:ea typeface="Be Vietnam Pro" pitchFamily="34" charset="-122"/>
+                <a:cs typeface="Be Vietnam Pro" pitchFamily="34" charset="-120"/>
+              </a:rPr>
+              <a:t> địa</a:t>
+            </a:r>
+            <a:r>
+              <a:rPr lang="en-US" sz="1950" dirty="0" spc="-1" kern="0">
+                <a:solidFill>
+                  <a:srgbClr val="D8D3C4"/>
+                </a:solidFill>
+                <a:latin typeface="Be Vietnam Pro" pitchFamily="34" charset="0"/>
+                <a:ea typeface="Be Vietnam Pro" pitchFamily="34" charset="-122"/>
+                <a:cs typeface="Be Vietnam Pro" pitchFamily="34" charset="-120"/>
+              </a:rPr>
+              <a:t> chỉ</a:t>
+            </a:r>
+            <a:r>
+              <a:rPr lang="en-US" sz="1950" dirty="0" spc="0" kern="0">
+                <a:solidFill>
+                  <a:srgbClr val="D8D3C4"/>
+                </a:solidFill>
+                <a:latin typeface="Be Vietnam Pro" pitchFamily="34" charset="0"/>
+                <a:ea typeface="Be Vietnam Pro" pitchFamily="34" charset="-122"/>
+                <a:cs typeface="Be Vietnam Pro" pitchFamily="34" charset="-120"/>
+              </a:rPr>
+              <a:t> IP:</a:t>
+            </a:r>
+            <a:r>
+              <a:rPr lang="en-US" sz="1950" dirty="0" spc="-3" kern="0">
+                <a:solidFill>
+                  <a:srgbClr val="D8D3C4"/>
+                </a:solidFill>
+                <a:latin typeface="Be Vietnam Pro" pitchFamily="34" charset="0"/>
+                <a:ea typeface="Be Vietnam Pro" pitchFamily="34" charset="-122"/>
+                <a:cs typeface="Be Vietnam Pro" pitchFamily="34" charset="-120"/>
+              </a:rPr>
+              <a:t> bốn</a:t>
+            </a:r>
+            <a:r>
+              <a:rPr lang="en-US" sz="1950" dirty="0" spc="-5" kern="0">
+                <a:solidFill>
+                  <a:srgbClr val="D8D3C4"/>
+                </a:solidFill>
+                <a:latin typeface="Be Vietnam Pro" pitchFamily="34" charset="0"/>
+                <a:ea typeface="Be Vietnam Pro" pitchFamily="34" charset="-122"/>
+                <a:cs typeface="Be Vietnam Pro" pitchFamily="34" charset="-120"/>
+              </a:rPr>
+              <a:t> số,</a:t>
+            </a:r>
+            <a:r>
+              <a:rPr lang="en-US" sz="1950" dirty="0" spc="-14" kern="0">
+                <a:solidFill>
+                  <a:srgbClr val="D8D3C4"/>
+                </a:solidFill>
+                <a:latin typeface="Be Vietnam Pro" pitchFamily="34" charset="0"/>
+                <a:ea typeface="Be Vietnam Pro" pitchFamily="34" charset="-122"/>
+                <a:cs typeface="Be Vietnam Pro" pitchFamily="34" charset="-120"/>
+              </a:rPr>
+              <a:t> và</a:t>
+            </a:r>
+            <a:r>
+              <a:rPr lang="en-US" sz="1950" dirty="0" spc="0" kern="0">
+                <a:solidFill>
+                  <a:srgbClr val="D8D3C4"/>
+                </a:solidFill>
+                <a:latin typeface="Be Vietnam Pro" pitchFamily="34" charset="0"/>
+                <a:ea typeface="Be Vietnam Pro" pitchFamily="34" charset="-122"/>
+                <a:cs typeface="Be Vietnam Pro" pitchFamily="34" charset="-120"/>
+              </a:rPr>
+              <a:t> kiểu mới</a:t>
+            </a:r>
+            <a:r>
+              <a:rPr lang="en-US" sz="1950" dirty="0" spc="-1" kern="0">
+                <a:solidFill>
+                  <a:srgbClr val="D8D3C4"/>
+                </a:solidFill>
+                <a:latin typeface="Be Vietnam Pro" pitchFamily="34" charset="0"/>
+                <a:ea typeface="Be Vietnam Pro" pitchFamily="34" charset="-122"/>
+                <a:cs typeface="Be Vietnam Pro" pitchFamily="34" charset="-120"/>
+              </a:rPr>
+              <a:t> dài</a:t>
+            </a:r>
+            <a:r>
+              <a:rPr lang="en-US" sz="1950" dirty="0" spc="0" kern="0">
+                <a:solidFill>
+                  <a:srgbClr val="D8D3C4"/>
+                </a:solidFill>
+                <a:latin typeface="Be Vietnam Pro" pitchFamily="34" charset="0"/>
+                <a:ea typeface="Be Vietnam Pro" pitchFamily="34" charset="-122"/>
+                <a:cs typeface="Be Vietnam Pro" pitchFamily="34" charset="-120"/>
+              </a:rPr>
+              <a:t> hơn.</a:t>
+            </a:r>
+            <a:endParaRPr lang="en-US" sz="1950" dirty="0"/>
+          </a:p>
+        </p:txBody>
+      </p:sp>
+      <p:sp>
+        <p:nvSpPr>
+          <p:cNvPr id="55" name="Shape 53"/>
           <p:cNvSpPr/>
           <p:nvPr/>
         </p:nvSpPr>
@@ -6687,7 +6681,7 @@
       </p:sp>
       <p:pic>
         <p:nvPicPr>
-          <p:cNvPr id="60" name="Moda image moda-export-watermark-2b936524-efa2-453d-891e-524d5f4a9d9c" descr="">    </p:cNvPr>
+          <p:cNvPr id="56" name="Moda image moda-export-watermark-2b936524-efa2-453d-891e-524d5f4a9d9c" descr="">    </p:cNvPr>
           <p:cNvPicPr>
             <a:picLocks noChangeAspect="1"/>
           </p:cNvPicPr>
@@ -14574,7 +14568,7 @@
               <a:t>Danh sách</a:t>
             </a:r>
             <a:r>
-              <a:rPr lang="en-US" sz="1950" dirty="0" spc="-2" kern="0">
+              <a:rPr lang="en-US" sz="1950" dirty="0" spc="0" kern="0">
                 <a:solidFill>
                   <a:srgbClr val="FFFFFF"/>
                 </a:solidFill>
@@ -14582,10 +14576,10 @@
                 <a:ea typeface="Be Vietnam Pro SemiBold" pitchFamily="34" charset="-122"/>
                 <a:cs typeface="Be Vietnam Pro SemiBold" pitchFamily="34" charset="-120"/>
               </a:rPr>
-              <a:t> là</a:t>
-            </a:r>
-            <a:r>
-              <a:rPr lang="en-US" sz="1950" dirty="0" spc="-1" kern="0">
+              <a:t> có</a:t>
+            </a:r>
+            <a:r>
+              <a:rPr lang="en-US" sz="1950" dirty="0" spc="-2" kern="0">
                 <a:solidFill>
                   <a:srgbClr val="FFFFFF"/>
                 </a:solidFill>
@@ -14593,10 +14587,10 @@
                 <a:ea typeface="Be Vietnam Pro SemiBold" pitchFamily="34" charset="-122"/>
                 <a:cs typeface="Be Vietnam Pro SemiBold" pitchFamily="34" charset="-120"/>
               </a:rPr>
-              <a:t> mọi</a:t>
-            </a:r>
-            <a:r>
-              <a:rPr lang="en-US" sz="1950" dirty="0" spc="12" kern="0">
+              <a:t> cả</a:t>
+            </a:r>
+            <a:r>
+              <a:rPr lang="en-US" sz="1950" dirty="0" spc="-3" kern="0">
                 <a:solidFill>
                   <a:srgbClr val="FFFFFF"/>
                 </a:solidFill>
@@ -14604,10 +14598,10 @@
                 <a:ea typeface="Be Vietnam Pro SemiBold" pitchFamily="34" charset="-122"/>
                 <a:cs typeface="Be Vietnam Pro SemiBold" pitchFamily="34" charset="-120"/>
               </a:rPr>
-              <a:t> địa</a:t>
-            </a:r>
-            <a:r>
-              <a:rPr lang="en-US" sz="1950" dirty="0" spc="-1" kern="0">
+              <a:t> IPv4</a:t>
+            </a:r>
+            <a:r>
+              <a:rPr lang="en-US" sz="1950" dirty="0" spc="0" kern="0">
                 <a:solidFill>
                   <a:srgbClr val="FFFFFF"/>
                 </a:solidFill>
@@ -14615,7 +14609,18 @@
                 <a:ea typeface="Be Vietnam Pro SemiBold" pitchFamily="34" charset="-122"/>
                 <a:cs typeface="Be Vietnam Pro SemiBold" pitchFamily="34" charset="-120"/>
               </a:rPr>
-              <a:t> chỉ</a:t>
+              <a:t> lẫn</a:t>
+            </a:r>
+            <a:r>
+              <a:rPr lang="en-US" sz="1950" dirty="0" spc="-11" kern="0">
+                <a:solidFill>
+                  <a:srgbClr val="FFFFFF"/>
+                </a:solidFill>
+                <a:latin typeface="Be Vietnam Pro SemiBold" pitchFamily="34" charset="0"/>
+                <a:ea typeface="Be Vietnam Pro SemiBold" pitchFamily="34" charset="-122"/>
+                <a:cs typeface="Be Vietnam Pro SemiBold" pitchFamily="34" charset="-120"/>
+              </a:rPr>
+              <a:t> IPv6</a:t>
             </a:r>
             <a:endParaRPr lang="en-US" sz="1950" dirty="0"/>
           </a:p>
@@ -14781,7 +14786,18 @@
                 <a:ea typeface="Be Vietnam Pro SemiBold" pitchFamily="34" charset="-122"/>
                 <a:cs typeface="Be Vietnam Pro SemiBold" pitchFamily="34" charset="-120"/>
               </a:rPr>
-              <a:t> 0.0.0.0/0</a:t>
+              <a:t> 0.0.0.0/0,</a:t>
+            </a:r>
+            <a:r>
+              <a:rPr lang="en-US" sz="2250" dirty="0" spc="2" kern="0">
+                <a:solidFill>
+                  <a:srgbClr val="14161C"/>
+                </a:solidFill>
+                <a:latin typeface="Be Vietnam Pro SemiBold" pitchFamily="34" charset="0"/>
+                <a:ea typeface="Be Vietnam Pro SemiBold" pitchFamily="34" charset="-122"/>
+                <a:cs typeface="Be Vietnam Pro SemiBold" pitchFamily="34" charset="-120"/>
+              </a:rPr>
+              <a:t> ::/0</a:t>
             </a:r>
             <a:endParaRPr lang="en-US" sz="2250" dirty="0"/>
           </a:p>
@@ -18133,10 +18149,10 @@
                 <a:ea typeface="Be Vietnam Pro SemiBold" pitchFamily="34" charset="-122"/>
                 <a:cs typeface="Be Vietnam Pro SemiBold" pitchFamily="34" charset="-120"/>
               </a:rPr>
-              <a:t>mọi</a:t>
-            </a:r>
-            <a:r>
-              <a:rPr lang="en-US" sz="2550" dirty="0" spc="20" kern="0">
+              <a:t>cả</a:t>
+            </a:r>
+            <a:r>
+              <a:rPr lang="en-US" sz="2550" dirty="0" spc="0" kern="0">
                 <a:solidFill>
                   <a:srgbClr val="F3EEE3"/>
                 </a:solidFill>
@@ -18144,10 +18160,10 @@
                 <a:ea typeface="Be Vietnam Pro SemiBold" pitchFamily="34" charset="-122"/>
                 <a:cs typeface="Be Vietnam Pro SemiBold" pitchFamily="34" charset="-120"/>
               </a:rPr>
-              <a:t> địa</a:t>
-            </a:r>
-            <a:r>
-              <a:rPr lang="en-US" sz="2550" dirty="0" spc="2" kern="0">
+              <a:t> IPv4</a:t>
+            </a:r>
+            <a:r>
+              <a:rPr lang="en-US" sz="2550" dirty="0" spc="-3" kern="0">
                 <a:solidFill>
                   <a:srgbClr val="F3EEE3"/>
                 </a:solidFill>
@@ -18155,7 +18171,18 @@
                 <a:ea typeface="Be Vietnam Pro SemiBold" pitchFamily="34" charset="-122"/>
                 <a:cs typeface="Be Vietnam Pro SemiBold" pitchFamily="34" charset="-120"/>
               </a:rPr>
-              <a:t> chỉ</a:t>
+              <a:t> lẫn</a:t>
+            </a:r>
+            <a:r>
+              <a:rPr lang="en-US" sz="2550" dirty="0" spc="-11" kern="0">
+                <a:solidFill>
+                  <a:srgbClr val="F3EEE3"/>
+                </a:solidFill>
+                <a:latin typeface="Be Vietnam Pro SemiBold" pitchFamily="34" charset="0"/>
+                <a:ea typeface="Be Vietnam Pro SemiBold" pitchFamily="34" charset="-122"/>
+                <a:cs typeface="Be Vietnam Pro SemiBold" pitchFamily="34" charset="-120"/>
+              </a:rPr>
+              <a:t> IPv6</a:t>
             </a:r>
             <a:endParaRPr lang="en-US" sz="2550" dirty="0"/>
           </a:p>
@@ -18199,6 +18226,15 @@
               </a:rPr>
               <a:t>AllowedIPs</a:t>
             </a:r>
+            <a:endParaRPr lang="en-US" sz="1950" dirty="0"/>
+          </a:p>
+          <a:p>
+            <a:pPr algn="l" indent="0" marL="0">
+              <a:lnSpc>
+                <a:spcPts val="2828"/>
+              </a:lnSpc>
+              <a:buNone/>
+            </a:pPr>
             <a:r>
               <a:rPr lang="en-US" sz="1950" dirty="0" spc="2" kern="0">
                 <a:solidFill>
@@ -18208,7 +18244,18 @@
                 <a:ea typeface="Be Vietnam Pro" pitchFamily="34" charset="-122"/>
                 <a:cs typeface="Be Vietnam Pro" pitchFamily="34" charset="-120"/>
               </a:rPr>
-              <a:t> 0.0.0.0/0</a:t>
+              <a:t>0.0.0.0/0,</a:t>
+            </a:r>
+            <a:r>
+              <a:rPr lang="en-US" sz="1950" dirty="0" spc="1" kern="0">
+                <a:solidFill>
+                  <a:srgbClr val="D8D3C4"/>
+                </a:solidFill>
+                <a:latin typeface="Be Vietnam Pro" pitchFamily="34" charset="0"/>
+                <a:ea typeface="Be Vietnam Pro" pitchFamily="34" charset="-122"/>
+                <a:cs typeface="Be Vietnam Pro" pitchFamily="34" charset="-120"/>
+              </a:rPr>
+              <a:t> ::/0</a:t>
             </a:r>
             <a:endParaRPr lang="en-US" sz="1950" dirty="0"/>
           </a:p>
@@ -23960,7 +24007,178 @@
       </p:sp>
       <p:sp>
         <p:nvSpPr>
-          <p:cNvPr id="58" name="Shape 56"/>
+          <p:cNvPr id="58" name="Text 56"/>
+          <p:cNvSpPr/>
+          <p:nvPr/>
+        </p:nvSpPr>
+        <p:spPr>
+          <a:xfrm>
+            <a:off x="914400" y="8972550"/>
+            <a:ext cx="14287500" cy="304800"/>
+          </a:xfrm>
+          <a:prstGeom prst="rect">
+            <a:avLst/>
+          </a:prstGeom>
+          <a:noFill/>
+          <a:ln/>
+        </p:spPr>
+        <p:txBody>
+          <a:bodyPr wrap="square" lIns="0" tIns="0" rIns="0" bIns="0" rtlCol="0" anchor="ctr"/>
+          <a:lstStyle/>
+          <a:p>
+            <a:pPr algn="l" indent="0" marL="0">
+              <a:buNone/>
+            </a:pPr>
+            <a:r>
+              <a:rPr lang="en-US" sz="1650" dirty="0" spc="2" kern="0">
+                <a:solidFill>
+                  <a:srgbClr val="9A98A0"/>
+                </a:solidFill>
+                <a:latin typeface="Be Vietnam Pro" pitchFamily="34" charset="0"/>
+                <a:ea typeface="Be Vietnam Pro" pitchFamily="34" charset="-122"/>
+                <a:cs typeface="Be Vietnam Pro" pitchFamily="34" charset="-120"/>
+              </a:rPr>
+              <a:t>Các</a:t>
+            </a:r>
+            <a:r>
+              <a:rPr lang="en-US" sz="1650" dirty="0" spc="-1" kern="0">
+                <a:solidFill>
+                  <a:srgbClr val="9A98A0"/>
+                </a:solidFill>
+                <a:latin typeface="Be Vietnam Pro" pitchFamily="34" charset="0"/>
+                <a:ea typeface="Be Vietnam Pro" pitchFamily="34" charset="-122"/>
+                <a:cs typeface="Be Vietnam Pro" pitchFamily="34" charset="-120"/>
+              </a:rPr>
+              <a:t> lần</a:t>
+            </a:r>
+            <a:r>
+              <a:rPr lang="en-US" sz="1650" dirty="0" spc="3" kern="0">
+                <a:solidFill>
+                  <a:srgbClr val="9A98A0"/>
+                </a:solidFill>
+                <a:latin typeface="Be Vietnam Pro" pitchFamily="34" charset="0"/>
+                <a:ea typeface="Be Vietnam Pro" pitchFamily="34" charset="-122"/>
+                <a:cs typeface="Be Vietnam Pro" pitchFamily="34" charset="-120"/>
+              </a:rPr>
+              <a:t> thử</a:t>
+            </a:r>
+            <a:r>
+              <a:rPr lang="en-US" sz="1650" dirty="0" spc="2" kern="0">
+                <a:solidFill>
+                  <a:srgbClr val="9A98A0"/>
+                </a:solidFill>
+                <a:latin typeface="Be Vietnam Pro" pitchFamily="34" charset="0"/>
+                <a:ea typeface="Be Vietnam Pro" pitchFamily="34" charset="-122"/>
+                <a:cs typeface="Be Vietnam Pro" pitchFamily="34" charset="-120"/>
+              </a:rPr>
+              <a:t> chỉ</a:t>
+            </a:r>
+            <a:r>
+              <a:rPr lang="en-US" sz="1650" dirty="0" spc="0" kern="0">
+                <a:solidFill>
+                  <a:srgbClr val="9A98A0"/>
+                </a:solidFill>
+                <a:latin typeface="Be Vietnam Pro" pitchFamily="34" charset="0"/>
+                <a:ea typeface="Be Vietnam Pro" pitchFamily="34" charset="-122"/>
+                <a:cs typeface="Be Vietnam Pro" pitchFamily="34" charset="-120"/>
+              </a:rPr>
+              <a:t> dùng IPv4.</a:t>
+            </a:r>
+            <a:r>
+              <a:rPr lang="en-US" sz="1650" dirty="0" spc="1" kern="0">
+                <a:solidFill>
+                  <a:srgbClr val="9A98A0"/>
+                </a:solidFill>
+                <a:latin typeface="Be Vietnam Pro" pitchFamily="34" charset="0"/>
+                <a:ea typeface="Be Vietnam Pro" pitchFamily="34" charset="-122"/>
+                <a:cs typeface="Be Vietnam Pro" pitchFamily="34" charset="-120"/>
+              </a:rPr>
+              <a:t> ::/0</a:t>
+            </a:r>
+            <a:r>
+              <a:rPr lang="en-US" sz="1650" dirty="0" spc="-6" kern="0">
+                <a:solidFill>
+                  <a:srgbClr val="9A98A0"/>
+                </a:solidFill>
+                <a:latin typeface="Be Vietnam Pro" pitchFamily="34" charset="0"/>
+                <a:ea typeface="Be Vietnam Pro" pitchFamily="34" charset="-122"/>
+                <a:cs typeface="Be Vietnam Pro" pitchFamily="34" charset="-120"/>
+              </a:rPr>
+              <a:t> lấy</a:t>
+            </a:r>
+            <a:r>
+              <a:rPr lang="en-US" sz="1650" dirty="0" spc="4" kern="0">
+                <a:solidFill>
+                  <a:srgbClr val="9A98A0"/>
+                </a:solidFill>
+                <a:latin typeface="Be Vietnam Pro" pitchFamily="34" charset="0"/>
+                <a:ea typeface="Be Vietnam Pro" pitchFamily="34" charset="-122"/>
+                <a:cs typeface="Be Vietnam Pro" pitchFamily="34" charset="-120"/>
+              </a:rPr>
+              <a:t> từ</a:t>
+            </a:r>
+            <a:r>
+              <a:rPr lang="en-US" sz="1650" dirty="0" spc="-1" kern="0">
+                <a:solidFill>
+                  <a:srgbClr val="9A98A0"/>
+                </a:solidFill>
+                <a:latin typeface="Be Vietnam Pro" pitchFamily="34" charset="0"/>
+                <a:ea typeface="Be Vietnam Pro" pitchFamily="34" charset="-122"/>
+                <a:cs typeface="Be Vietnam Pro" pitchFamily="34" charset="-120"/>
+              </a:rPr>
+              <a:t> man</a:t>
+            </a:r>
+            <a:r>
+              <a:rPr lang="en-US" sz="1650" dirty="0" spc="-8" kern="0">
+                <a:solidFill>
+                  <a:srgbClr val="9A98A0"/>
+                </a:solidFill>
+                <a:latin typeface="Be Vietnam Pro" pitchFamily="34" charset="0"/>
+                <a:ea typeface="Be Vietnam Pro" pitchFamily="34" charset="-122"/>
+                <a:cs typeface="Be Vietnam Pro" pitchFamily="34" charset="-120"/>
+              </a:rPr>
+              <a:t> page wg,</a:t>
+            </a:r>
+            <a:r>
+              <a:rPr lang="en-US" sz="1650" dirty="0" spc="5" kern="0">
+                <a:solidFill>
+                  <a:srgbClr val="9A98A0"/>
+                </a:solidFill>
+                <a:latin typeface="Be Vietnam Pro" pitchFamily="34" charset="0"/>
+                <a:ea typeface="Be Vietnam Pro" pitchFamily="34" charset="-122"/>
+                <a:cs typeface="Be Vietnam Pro" pitchFamily="34" charset="-120"/>
+              </a:rPr>
+              <a:t> chưa</a:t>
+            </a:r>
+            <a:r>
+              <a:rPr lang="en-US" sz="1650" dirty="0" spc="-4" kern="0">
+                <a:solidFill>
+                  <a:srgbClr val="9A98A0"/>
+                </a:solidFill>
+                <a:latin typeface="Be Vietnam Pro" pitchFamily="34" charset="0"/>
+                <a:ea typeface="Be Vietnam Pro" pitchFamily="34" charset="-122"/>
+                <a:cs typeface="Be Vietnam Pro" pitchFamily="34" charset="-120"/>
+              </a:rPr>
+              <a:t> chạy</a:t>
+            </a:r>
+            <a:r>
+              <a:rPr lang="en-US" sz="1650" dirty="0" spc="1" kern="0">
+                <a:solidFill>
+                  <a:srgbClr val="9A98A0"/>
+                </a:solidFill>
+                <a:latin typeface="Be Vietnam Pro" pitchFamily="34" charset="0"/>
+                <a:ea typeface="Be Vietnam Pro" pitchFamily="34" charset="-122"/>
+                <a:cs typeface="Be Vietnam Pro" pitchFamily="34" charset="-120"/>
+              </a:rPr>
+              <a:t> thử.</a:t>
+            </a:r>
+            <a:endParaRPr lang="en-US" sz="1650" dirty="0"/>
+          </a:p>
+        </p:txBody>
+      </p:sp>
+      <p:sp>
+        <p:nvSpPr>
+          <p:cNvPr id="59" name="Shape 57"/>
           <p:cNvSpPr/>
           <p:nvPr/>
         </p:nvSpPr>
@@ -23984,7 +24202,7 @@
       </p:sp>
       <p:pic>
         <p:nvPicPr>
-          <p:cNvPr id="59" name="Moda image moda-export-watermark-11c2de07-23b3-440a-a613-a4023b5ac98b" descr="">    </p:cNvPr>
+          <p:cNvPr id="60" name="Moda image moda-export-watermark-11c2de07-23b3-440a-a613-a4023b5ac98b" descr="">    </p:cNvPr>
           <p:cNvPicPr>
             <a:picLocks noChangeAspect="1"/>
           </p:cNvPicPr>
@@ -25359,7 +25577,7 @@
         <p:spPr>
           <a:xfrm>
             <a:off x="10972800" y="6115050"/>
-            <a:ext cx="6019800" cy="1047750"/>
+            <a:ext cx="6019800" cy="952500"/>
           </a:xfrm>
           <a:prstGeom prst="rect">
             <a:avLst/>
@@ -25400,7 +25618,7 @@
               <a:t> 0.0.0.0/0,</a:t>
             </a:r>
             <a:r>
-              <a:rPr lang="en-US" sz="2400" dirty="0" spc="4" kern="0">
+              <a:rPr lang="en-US" sz="2400" dirty="0" spc="-1" kern="0">
                 <a:solidFill>
                   <a:srgbClr val="FFFFFF"/>
                 </a:solidFill>
@@ -25408,10 +25626,19 @@
                 <a:ea typeface="Be Vietnam Pro" pitchFamily="34" charset="-122"/>
                 <a:cs typeface="Be Vietnam Pro" pitchFamily="34" charset="-120"/>
               </a:rPr>
-              <a:t> giữ</a:t>
-            </a:r>
-            <a:r>
-              <a:rPr lang="en-US" sz="2400" dirty="0" spc="7" kern="0">
+              <a:t> ::/0:</a:t>
+            </a:r>
+            <a:endParaRPr lang="en-US" sz="2400" dirty="0"/>
+          </a:p>
+          <a:p>
+            <a:pPr algn="l" indent="0" marL="0">
+              <a:lnSpc>
+                <a:spcPts val="3360"/>
+              </a:lnSpc>
+              <a:buNone/>
+            </a:pPr>
+            <a:r>
+              <a:rPr lang="en-US" sz="2400" dirty="0" spc="0" kern="0">
                 <a:solidFill>
                   <a:srgbClr val="FFFFFF"/>
                 </a:solidFill>
@@ -25419,10 +25646,10 @@
                 <a:ea typeface="Be Vietnam Pro" pitchFamily="34" charset="-122"/>
                 <a:cs typeface="Be Vietnam Pro" pitchFamily="34" charset="-120"/>
               </a:rPr>
-              <a:t> đường</a:t>
-            </a:r>
-            <a:r>
-              <a:rPr lang="en-US" sz="2400" dirty="0" spc="9" kern="0">
+              <a:t>cả</a:t>
+            </a:r>
+            <a:r>
+              <a:rPr lang="en-US" sz="2400" dirty="0" spc="-2" kern="0">
                 <a:solidFill>
                   <a:srgbClr val="FFFFFF"/>
                 </a:solidFill>
@@ -25430,7 +25657,18 @@
                 <a:ea typeface="Be Vietnam Pro" pitchFamily="34" charset="-122"/>
                 <a:cs typeface="Be Vietnam Pro" pitchFamily="34" charset="-120"/>
               </a:rPr>
-              <a:t> riêng</a:t>
+              <a:t> IPv4</a:t>
+            </a:r>
+            <a:r>
+              <a:rPr lang="en-US" sz="2400" dirty="0" spc="2" kern="0">
+                <a:solidFill>
+                  <a:srgbClr val="FFFFFF"/>
+                </a:solidFill>
+                <a:latin typeface="Be Vietnam Pro" pitchFamily="34" charset="0"/>
+                <a:ea typeface="Be Vietnam Pro" pitchFamily="34" charset="-122"/>
+                <a:cs typeface="Be Vietnam Pro" pitchFamily="34" charset="-120"/>
+              </a:rPr>
+              <a:t> lẫn</a:t>
             </a:r>
             <a:r>
               <a:rPr lang="en-US" sz="2400" dirty="0" spc="-11" kern="0">
@@ -25441,40 +25679,7 @@
                 <a:ea typeface="Be Vietnam Pro" pitchFamily="34" charset="-122"/>
                 <a:cs typeface="Be Vietnam Pro" pitchFamily="34" charset="-120"/>
               </a:rPr>
-              <a:t> tới</a:t>
-            </a:r>
-            <a:r>
-              <a:rPr lang="en-US" sz="2400" dirty="0" spc="-7" kern="0">
-                <a:solidFill>
-                  <a:srgbClr val="FFFFFF"/>
-                </a:solidFill>
-                <a:latin typeface="Be Vietnam Pro" pitchFamily="34" charset="0"/>
-                <a:ea typeface="Be Vietnam Pro" pitchFamily="34" charset="-122"/>
-                <a:cs typeface="Be Vietnam Pro" pitchFamily="34" charset="-120"/>
-              </a:rPr>
-              <a:t> máy</a:t>
-            </a:r>
-            <a:r>
-              <a:rPr lang="en-US" sz="2400" dirty="0" spc="1" kern="0">
-                <a:solidFill>
-                  <a:srgbClr val="FFFFFF"/>
-                </a:solidFill>
-                <a:latin typeface="Be Vietnam Pro" pitchFamily="34" charset="0"/>
-                <a:ea typeface="Be Vietnam Pro" pitchFamily="34" charset="-122"/>
-                <a:cs typeface="Be Vietnam Pro" pitchFamily="34" charset="-120"/>
-              </a:rPr>
-              <a:t> chủ</a:t>
-            </a:r>
-            <a:r>
-              <a:rPr lang="en-US" sz="2400" dirty="0" spc="-3" kern="0">
-                <a:solidFill>
-                  <a:srgbClr val="FFFFFF"/>
-                </a:solidFill>
-                <a:latin typeface="Be Vietnam Pro" pitchFamily="34" charset="0"/>
-                <a:ea typeface="Be Vietnam Pro" pitchFamily="34" charset="-122"/>
-                <a:cs typeface="Be Vietnam Pro" pitchFamily="34" charset="-120"/>
-              </a:rPr>
-              <a:t> VPN.</a:t>
+              <a:t> IPv6.</a:t>
             </a:r>
             <a:endParaRPr lang="en-US" sz="2400" dirty="0"/>
           </a:p>
@@ -25488,8 +25693,8 @@
         </p:nvSpPr>
         <p:spPr>
           <a:xfrm>
-            <a:off x="10972800" y="7258050"/>
-            <a:ext cx="6019800" cy="952500"/>
+            <a:off x="10972800" y="7124700"/>
+            <a:ext cx="6019800" cy="1619250"/>
           </a:xfrm>
           <a:prstGeom prst="rect">
             <a:avLst/>
@@ -25505,6 +25710,9 @@
               <a:lnSpc>
                 <a:spcPts val="2940"/>
               </a:lnSpc>
+              <a:spcAft>
+                <a:spcPts val="600"/>
+              </a:spcAft>
               <a:buNone/>
             </a:pPr>
             <a:r>
@@ -25516,7 +25724,181 @@
                 <a:ea typeface="Be Vietnam Pro" pitchFamily="34" charset="-122"/>
                 <a:cs typeface="Be Vietnam Pro" pitchFamily="34" charset="-120"/>
               </a:rPr>
-              <a:t>Nếu</a:t>
+              <a:t>Chỉ</a:t>
+            </a:r>
+            <a:r>
+              <a:rPr lang="en-US" sz="2100" dirty="0" spc="-3" kern="0">
+                <a:solidFill>
+                  <a:srgbClr val="DDE3FA"/>
+                </a:solidFill>
+                <a:latin typeface="Be Vietnam Pro" pitchFamily="34" charset="0"/>
+                <a:ea typeface="Be Vietnam Pro" pitchFamily="34" charset="-122"/>
+                <a:cs typeface="Be Vietnam Pro" pitchFamily="34" charset="-120"/>
+              </a:rPr>
+              <a:t> có</a:t>
+            </a:r>
+            <a:r>
+              <a:rPr lang="en-US" sz="2100" dirty="0" spc="-4" kern="0">
+                <a:solidFill>
+                  <a:srgbClr val="DDE3FA"/>
+                </a:solidFill>
+                <a:latin typeface="Be Vietnam Pro" pitchFamily="34" charset="0"/>
+                <a:ea typeface="Be Vietnam Pro" pitchFamily="34" charset="-122"/>
+                <a:cs typeface="Be Vietnam Pro" pitchFamily="34" charset="-120"/>
+              </a:rPr>
+              <a:t> 0.0.0.0/0</a:t>
+            </a:r>
+            <a:r>
+              <a:rPr lang="en-US" sz="2100" dirty="0" spc="0" kern="0">
+                <a:solidFill>
+                  <a:srgbClr val="DDE3FA"/>
+                </a:solidFill>
+                <a:latin typeface="Be Vietnam Pro" pitchFamily="34" charset="0"/>
+                <a:ea typeface="Be Vietnam Pro" pitchFamily="34" charset="-122"/>
+                <a:cs typeface="Be Vietnam Pro" pitchFamily="34" charset="-120"/>
+              </a:rPr>
+              <a:t> thì</a:t>
+            </a:r>
+            <a:r>
+              <a:rPr lang="en-US" sz="2100" dirty="0" spc="-12" kern="0">
+                <a:solidFill>
+                  <a:srgbClr val="DDE3FA"/>
+                </a:solidFill>
+                <a:latin typeface="Be Vietnam Pro" pitchFamily="34" charset="0"/>
+                <a:ea typeface="Be Vietnam Pro" pitchFamily="34" charset="-122"/>
+                <a:cs typeface="Be Vietnam Pro" pitchFamily="34" charset="-120"/>
+              </a:rPr>
+              <a:t> gói</a:t>
+            </a:r>
+            <a:r>
+              <a:rPr lang="en-US" sz="2100" dirty="0" spc="-8" kern="0">
+                <a:solidFill>
+                  <a:srgbClr val="DDE3FA"/>
+                </a:solidFill>
+                <a:latin typeface="Be Vietnam Pro" pitchFamily="34" charset="0"/>
+                <a:ea typeface="Be Vietnam Pro" pitchFamily="34" charset="-122"/>
+                <a:cs typeface="Be Vietnam Pro" pitchFamily="34" charset="-120"/>
+              </a:rPr>
+              <a:t> IPv6</a:t>
+            </a:r>
+            <a:r>
+              <a:rPr lang="en-US" sz="2100" dirty="0" spc="-12" kern="0">
+                <a:solidFill>
+                  <a:srgbClr val="DDE3FA"/>
+                </a:solidFill>
+                <a:latin typeface="Be Vietnam Pro" pitchFamily="34" charset="0"/>
+                <a:ea typeface="Be Vietnam Pro" pitchFamily="34" charset="-122"/>
+                <a:cs typeface="Be Vietnam Pro" pitchFamily="34" charset="-120"/>
+              </a:rPr>
+              <a:t> vẫn</a:t>
+            </a:r>
+            <a:r>
+              <a:rPr lang="en-US" sz="2100" dirty="0" spc="29" kern="0">
+                <a:solidFill>
+                  <a:srgbClr val="DDE3FA"/>
+                </a:solidFill>
+                <a:latin typeface="Be Vietnam Pro" pitchFamily="34" charset="0"/>
+                <a:ea typeface="Be Vietnam Pro" pitchFamily="34" charset="-122"/>
+                <a:cs typeface="Be Vietnam Pro" pitchFamily="34" charset="-120"/>
+              </a:rPr>
+              <a:t> đi</a:t>
+            </a:r>
+            <a:r>
+              <a:rPr lang="en-US" sz="2100" dirty="0" spc="-1" kern="0">
+                <a:solidFill>
+                  <a:srgbClr val="DDE3FA"/>
+                </a:solidFill>
+                <a:latin typeface="Be Vietnam Pro" pitchFamily="34" charset="0"/>
+                <a:ea typeface="Be Vietnam Pro" pitchFamily="34" charset="-122"/>
+                <a:cs typeface="Be Vietnam Pro" pitchFamily="34" charset="-120"/>
+              </a:rPr>
+              <a:t> thẳng.</a:t>
+            </a:r>
+            <a:endParaRPr lang="en-US" sz="2100" dirty="0"/>
+          </a:p>
+          <a:p>
+            <a:pPr algn="l" indent="0" marL="0">
+              <a:lnSpc>
+                <a:spcPts val="2940"/>
+              </a:lnSpc>
+              <a:buNone/>
+            </a:pPr>
+            <a:r>
+              <a:rPr lang="en-US" sz="2100" dirty="0" spc="1" kern="0">
+                <a:solidFill>
+                  <a:srgbClr val="DDE3FA"/>
+                </a:solidFill>
+                <a:latin typeface="Be Vietnam Pro" pitchFamily="34" charset="0"/>
+                <a:ea typeface="Be Vietnam Pro" pitchFamily="34" charset="-122"/>
+                <a:cs typeface="Be Vietnam Pro" pitchFamily="34" charset="-120"/>
+              </a:rPr>
+              <a:t>Giữ</a:t>
+            </a:r>
+            <a:r>
+              <a:rPr lang="en-US" sz="2100" dirty="0" spc="4" kern="0">
+                <a:solidFill>
+                  <a:srgbClr val="DDE3FA"/>
+                </a:solidFill>
+                <a:latin typeface="Be Vietnam Pro" pitchFamily="34" charset="0"/>
+                <a:ea typeface="Be Vietnam Pro" pitchFamily="34" charset="-122"/>
+                <a:cs typeface="Be Vietnam Pro" pitchFamily="34" charset="-120"/>
+              </a:rPr>
+              <a:t> đường</a:t>
+            </a:r>
+            <a:r>
+              <a:rPr lang="en-US" sz="2100" dirty="0" spc="8" kern="0">
+                <a:solidFill>
+                  <a:srgbClr val="DDE3FA"/>
+                </a:solidFill>
+                <a:latin typeface="Be Vietnam Pro" pitchFamily="34" charset="0"/>
+                <a:ea typeface="Be Vietnam Pro" pitchFamily="34" charset="-122"/>
+                <a:cs typeface="Be Vietnam Pro" pitchFamily="34" charset="-120"/>
+              </a:rPr>
+              <a:t> riêng</a:t>
+            </a:r>
+            <a:r>
+              <a:rPr lang="en-US" sz="2100" dirty="0" spc="-12" kern="0">
+                <a:solidFill>
+                  <a:srgbClr val="DDE3FA"/>
+                </a:solidFill>
+                <a:latin typeface="Be Vietnam Pro" pitchFamily="34" charset="0"/>
+                <a:ea typeface="Be Vietnam Pro" pitchFamily="34" charset="-122"/>
+                <a:cs typeface="Be Vietnam Pro" pitchFamily="34" charset="-120"/>
+              </a:rPr>
+              <a:t> tới</a:t>
+            </a:r>
+            <a:r>
+              <a:rPr lang="en-US" sz="2100" dirty="0" spc="-10" kern="0">
+                <a:solidFill>
+                  <a:srgbClr val="DDE3FA"/>
+                </a:solidFill>
+                <a:latin typeface="Be Vietnam Pro" pitchFamily="34" charset="0"/>
+                <a:ea typeface="Be Vietnam Pro" pitchFamily="34" charset="-122"/>
+                <a:cs typeface="Be Vietnam Pro" pitchFamily="34" charset="-120"/>
+              </a:rPr>
+              <a:t> máy</a:t>
+            </a:r>
+            <a:r>
+              <a:rPr lang="en-US" sz="2100" dirty="0" spc="-1" kern="0">
+                <a:solidFill>
+                  <a:srgbClr val="DDE3FA"/>
+                </a:solidFill>
+                <a:latin typeface="Be Vietnam Pro" pitchFamily="34" charset="0"/>
+                <a:ea typeface="Be Vietnam Pro" pitchFamily="34" charset="-122"/>
+                <a:cs typeface="Be Vietnam Pro" pitchFamily="34" charset="-120"/>
+              </a:rPr>
+              <a:t> chủ VPN.</a:t>
+            </a:r>
+            <a:r>
+              <a:rPr lang="en-US" sz="2100" dirty="0" spc="0" kern="0">
+                <a:solidFill>
+                  <a:srgbClr val="DDE3FA"/>
+                </a:solidFill>
+                <a:latin typeface="Be Vietnam Pro" pitchFamily="34" charset="0"/>
+                <a:ea typeface="Be Vietnam Pro" pitchFamily="34" charset="-122"/>
+                <a:cs typeface="Be Vietnam Pro" pitchFamily="34" charset="-120"/>
+              </a:rPr>
+              <a:t> Nếu</a:t>
             </a:r>
             <a:r>
               <a:rPr lang="en-US" sz="2100" dirty="0" spc="-1" kern="0">

</xml_diff>